<commit_message>
Changed Animations Chunk 1-6, added private projects to chunk 1
</commit_message>
<xml_diff>
--- a/Lecture Resources/Lecture Powerpoints/Chunk 3 - Logic Operators and If-Statements.pptx
+++ b/Lecture Resources/Lecture Powerpoints/Chunk 3 - Logic Operators and If-Statements.pptx
@@ -125,6 +125,248 @@
 </p:presentation>
 </file>
 
+<file path=ppt/revisionInfo.xml><?xml version="1.0" encoding="utf-8"?>
+<p1510:revInfo xmlns:a="http://schemas.openxmlformats.org/drawingml/2006/main" xmlns:r="http://schemas.openxmlformats.org/officeDocument/2006/relationships" xmlns:p1510="http://schemas.microsoft.com/office/powerpoint/2015/10/main">
+  <p1510:revLst>
+    <p1510:client id="{C242859E-5246-40F2-85A4-0082721AC05F}" v="13" dt="2025-10-07T22:35:54.621"/>
+  </p1510:revLst>
+</p1510:revInfo>
+</file>
+
+<file path=ppt/changesInfos/changesInfo1.xml><?xml version="1.0" encoding="utf-8"?>
+<pc:chgInfo xmlns:a="http://schemas.openxmlformats.org/drawingml/2006/main" xmlns:r="http://schemas.openxmlformats.org/officeDocument/2006/relationships" xmlns:ac="http://schemas.microsoft.com/office/drawing/2013/main/command" xmlns:pc="http://schemas.microsoft.com/office/powerpoint/2013/main/command">
+  <pc:docChgLst>
+    <pc:chgData name="Jonathan Bollig" userId="8b5d0afe-f106-45e0-8c3f-fd98fa124db1" providerId="ADAL" clId="{B2469FA9-EBD8-4834-A16D-CBF8EFC907DD}"/>
+    <pc:docChg chg="modSld">
+      <pc:chgData name="Jonathan Bollig" userId="8b5d0afe-f106-45e0-8c3f-fd98fa124db1" providerId="ADAL" clId="{B2469FA9-EBD8-4834-A16D-CBF8EFC907DD}" dt="2025-10-07T22:35:54.621" v="12"/>
+      <pc:docMkLst>
+        <pc:docMk/>
+      </pc:docMkLst>
+      <pc:sldChg chg="addSp modSp modAnim">
+        <pc:chgData name="Jonathan Bollig" userId="8b5d0afe-f106-45e0-8c3f-fd98fa124db1" providerId="ADAL" clId="{B2469FA9-EBD8-4834-A16D-CBF8EFC907DD}" dt="2025-10-07T22:32:39.148" v="3"/>
+        <pc:sldMkLst>
+          <pc:docMk/>
+          <pc:sldMk cId="520036874" sldId="261"/>
+        </pc:sldMkLst>
+        <pc:spChg chg="mod">
+          <ac:chgData name="Jonathan Bollig" userId="8b5d0afe-f106-45e0-8c3f-fd98fa124db1" providerId="ADAL" clId="{B2469FA9-EBD8-4834-A16D-CBF8EFC907DD}" dt="2025-10-07T22:32:37.973" v="2" actId="164"/>
+          <ac:spMkLst>
+            <pc:docMk/>
+            <pc:sldMk cId="520036874" sldId="261"/>
+            <ac:spMk id="26" creationId="{4B049117-E240-0C19-5590-9BED9B0BF43E}"/>
+          </ac:spMkLst>
+        </pc:spChg>
+        <pc:spChg chg="mod">
+          <ac:chgData name="Jonathan Bollig" userId="8b5d0afe-f106-45e0-8c3f-fd98fa124db1" providerId="ADAL" clId="{B2469FA9-EBD8-4834-A16D-CBF8EFC907DD}" dt="2025-10-07T22:32:37.973" v="2" actId="164"/>
+          <ac:spMkLst>
+            <pc:docMk/>
+            <pc:sldMk cId="520036874" sldId="261"/>
+            <ac:spMk id="27" creationId="{134167D6-D2FE-01AF-B753-C0FC4968D4E7}"/>
+          </ac:spMkLst>
+        </pc:spChg>
+        <pc:grpChg chg="add mod">
+          <ac:chgData name="Jonathan Bollig" userId="8b5d0afe-f106-45e0-8c3f-fd98fa124db1" providerId="ADAL" clId="{B2469FA9-EBD8-4834-A16D-CBF8EFC907DD}" dt="2025-10-07T22:32:37.973" v="2" actId="164"/>
+          <ac:grpSpMkLst>
+            <pc:docMk/>
+            <pc:sldMk cId="520036874" sldId="261"/>
+            <ac:grpSpMk id="10" creationId="{DBB487A3-BB4E-7B99-B021-53FFB4397574}"/>
+          </ac:grpSpMkLst>
+        </pc:grpChg>
+        <pc:picChg chg="mod">
+          <ac:chgData name="Jonathan Bollig" userId="8b5d0afe-f106-45e0-8c3f-fd98fa124db1" providerId="ADAL" clId="{B2469FA9-EBD8-4834-A16D-CBF8EFC907DD}" dt="2025-10-07T22:32:37.973" v="2" actId="164"/>
+          <ac:picMkLst>
+            <pc:docMk/>
+            <pc:sldMk cId="520036874" sldId="261"/>
+            <ac:picMk id="25" creationId="{DFCB6EC6-58E9-F445-8D98-BFE79365B557}"/>
+          </ac:picMkLst>
+        </pc:picChg>
+      </pc:sldChg>
+      <pc:sldChg chg="addSp modSp modAnim">
+        <pc:chgData name="Jonathan Bollig" userId="8b5d0afe-f106-45e0-8c3f-fd98fa124db1" providerId="ADAL" clId="{B2469FA9-EBD8-4834-A16D-CBF8EFC907DD}" dt="2025-10-07T22:34:57.818" v="8"/>
+        <pc:sldMkLst>
+          <pc:docMk/>
+          <pc:sldMk cId="539501943" sldId="264"/>
+        </pc:sldMkLst>
+        <pc:spChg chg="mod">
+          <ac:chgData name="Jonathan Bollig" userId="8b5d0afe-f106-45e0-8c3f-fd98fa124db1" providerId="ADAL" clId="{B2469FA9-EBD8-4834-A16D-CBF8EFC907DD}" dt="2025-10-07T22:34:48.750" v="5" actId="164"/>
+          <ac:spMkLst>
+            <pc:docMk/>
+            <pc:sldMk cId="539501943" sldId="264"/>
+            <ac:spMk id="4" creationId="{4FCF54D6-4A6D-35CE-6FC9-39D50CE85FF2}"/>
+          </ac:spMkLst>
+        </pc:spChg>
+        <pc:spChg chg="mod">
+          <ac:chgData name="Jonathan Bollig" userId="8b5d0afe-f106-45e0-8c3f-fd98fa124db1" providerId="ADAL" clId="{B2469FA9-EBD8-4834-A16D-CBF8EFC907DD}" dt="2025-10-07T22:34:48.750" v="5" actId="164"/>
+          <ac:spMkLst>
+            <pc:docMk/>
+            <pc:sldMk cId="539501943" sldId="264"/>
+            <ac:spMk id="5" creationId="{0F270356-AFF2-A7FA-15E6-E6C505BCC5C9}"/>
+          </ac:spMkLst>
+        </pc:spChg>
+        <pc:spChg chg="mod">
+          <ac:chgData name="Jonathan Bollig" userId="8b5d0afe-f106-45e0-8c3f-fd98fa124db1" providerId="ADAL" clId="{B2469FA9-EBD8-4834-A16D-CBF8EFC907DD}" dt="2025-10-07T22:34:48.750" v="5" actId="164"/>
+          <ac:spMkLst>
+            <pc:docMk/>
+            <pc:sldMk cId="539501943" sldId="264"/>
+            <ac:spMk id="6" creationId="{80648EA6-2644-D128-38C0-3C28778A272B}"/>
+          </ac:spMkLst>
+        </pc:spChg>
+        <pc:spChg chg="mod">
+          <ac:chgData name="Jonathan Bollig" userId="8b5d0afe-f106-45e0-8c3f-fd98fa124db1" providerId="ADAL" clId="{B2469FA9-EBD8-4834-A16D-CBF8EFC907DD}" dt="2025-10-07T22:34:48.750" v="5" actId="164"/>
+          <ac:spMkLst>
+            <pc:docMk/>
+            <pc:sldMk cId="539501943" sldId="264"/>
+            <ac:spMk id="7" creationId="{7D63D7FB-DAFA-DF99-F517-9119FC1AC9C0}"/>
+          </ac:spMkLst>
+        </pc:spChg>
+        <pc:spChg chg="mod">
+          <ac:chgData name="Jonathan Bollig" userId="8b5d0afe-f106-45e0-8c3f-fd98fa124db1" providerId="ADAL" clId="{B2469FA9-EBD8-4834-A16D-CBF8EFC907DD}" dt="2025-10-07T22:34:48.750" v="5" actId="164"/>
+          <ac:spMkLst>
+            <pc:docMk/>
+            <pc:sldMk cId="539501943" sldId="264"/>
+            <ac:spMk id="12" creationId="{0F4CBEE2-754A-BF38-DB4B-DC6A6F16BD1E}"/>
+          </ac:spMkLst>
+        </pc:spChg>
+        <pc:spChg chg="mod">
+          <ac:chgData name="Jonathan Bollig" userId="8b5d0afe-f106-45e0-8c3f-fd98fa124db1" providerId="ADAL" clId="{B2469FA9-EBD8-4834-A16D-CBF8EFC907DD}" dt="2025-10-07T22:34:48.750" v="5" actId="164"/>
+          <ac:spMkLst>
+            <pc:docMk/>
+            <pc:sldMk cId="539501943" sldId="264"/>
+            <ac:spMk id="13" creationId="{6C12A045-772B-0FBE-AC43-41C8BBD9E99B}"/>
+          </ac:spMkLst>
+        </pc:spChg>
+        <pc:spChg chg="mod">
+          <ac:chgData name="Jonathan Bollig" userId="8b5d0afe-f106-45e0-8c3f-fd98fa124db1" providerId="ADAL" clId="{B2469FA9-EBD8-4834-A16D-CBF8EFC907DD}" dt="2025-10-07T22:34:48.750" v="5" actId="164"/>
+          <ac:spMkLst>
+            <pc:docMk/>
+            <pc:sldMk cId="539501943" sldId="264"/>
+            <ac:spMk id="16" creationId="{F1DBB668-4150-1DE3-13CE-53CC70D585A6}"/>
+          </ac:spMkLst>
+        </pc:spChg>
+        <pc:spChg chg="mod">
+          <ac:chgData name="Jonathan Bollig" userId="8b5d0afe-f106-45e0-8c3f-fd98fa124db1" providerId="ADAL" clId="{B2469FA9-EBD8-4834-A16D-CBF8EFC907DD}" dt="2025-10-07T22:34:42.201" v="4" actId="164"/>
+          <ac:spMkLst>
+            <pc:docMk/>
+            <pc:sldMk cId="539501943" sldId="264"/>
+            <ac:spMk id="37" creationId="{E63E1191-2AD7-F354-BD40-5C33059EB9DE}"/>
+          </ac:spMkLst>
+        </pc:spChg>
+        <pc:spChg chg="mod">
+          <ac:chgData name="Jonathan Bollig" userId="8b5d0afe-f106-45e0-8c3f-fd98fa124db1" providerId="ADAL" clId="{B2469FA9-EBD8-4834-A16D-CBF8EFC907DD}" dt="2025-10-07T22:34:42.201" v="4" actId="164"/>
+          <ac:spMkLst>
+            <pc:docMk/>
+            <pc:sldMk cId="539501943" sldId="264"/>
+            <ac:spMk id="38" creationId="{9F45DB8C-28F2-F23D-79DC-3A8BA3E30F61}"/>
+          </ac:spMkLst>
+        </pc:spChg>
+        <pc:spChg chg="mod">
+          <ac:chgData name="Jonathan Bollig" userId="8b5d0afe-f106-45e0-8c3f-fd98fa124db1" providerId="ADAL" clId="{B2469FA9-EBD8-4834-A16D-CBF8EFC907DD}" dt="2025-10-07T22:34:42.201" v="4" actId="164"/>
+          <ac:spMkLst>
+            <pc:docMk/>
+            <pc:sldMk cId="539501943" sldId="264"/>
+            <ac:spMk id="39" creationId="{CCCAAA7C-4625-CAE3-40BE-A672B37E9FDF}"/>
+          </ac:spMkLst>
+        </pc:spChg>
+        <pc:spChg chg="mod">
+          <ac:chgData name="Jonathan Bollig" userId="8b5d0afe-f106-45e0-8c3f-fd98fa124db1" providerId="ADAL" clId="{B2469FA9-EBD8-4834-A16D-CBF8EFC907DD}" dt="2025-10-07T22:34:42.201" v="4" actId="164"/>
+          <ac:spMkLst>
+            <pc:docMk/>
+            <pc:sldMk cId="539501943" sldId="264"/>
+            <ac:spMk id="40" creationId="{E868DF51-CBF5-34F3-2FB6-F47074E84AB7}"/>
+          </ac:spMkLst>
+        </pc:spChg>
+        <pc:spChg chg="mod">
+          <ac:chgData name="Jonathan Bollig" userId="8b5d0afe-f106-45e0-8c3f-fd98fa124db1" providerId="ADAL" clId="{B2469FA9-EBD8-4834-A16D-CBF8EFC907DD}" dt="2025-10-07T22:34:42.201" v="4" actId="164"/>
+          <ac:spMkLst>
+            <pc:docMk/>
+            <pc:sldMk cId="539501943" sldId="264"/>
+            <ac:spMk id="45" creationId="{4F2C637F-8D54-8E10-2820-74622DED5FB7}"/>
+          </ac:spMkLst>
+        </pc:spChg>
+        <pc:spChg chg="mod">
+          <ac:chgData name="Jonathan Bollig" userId="8b5d0afe-f106-45e0-8c3f-fd98fa124db1" providerId="ADAL" clId="{B2469FA9-EBD8-4834-A16D-CBF8EFC907DD}" dt="2025-10-07T22:34:42.201" v="4" actId="164"/>
+          <ac:spMkLst>
+            <pc:docMk/>
+            <pc:sldMk cId="539501943" sldId="264"/>
+            <ac:spMk id="46" creationId="{6CD50F20-C952-4A74-1884-F8CADA83CF0E}"/>
+          </ac:spMkLst>
+        </pc:spChg>
+        <pc:grpChg chg="add mod">
+          <ac:chgData name="Jonathan Bollig" userId="8b5d0afe-f106-45e0-8c3f-fd98fa124db1" providerId="ADAL" clId="{B2469FA9-EBD8-4834-A16D-CBF8EFC907DD}" dt="2025-10-07T22:34:42.201" v="4" actId="164"/>
+          <ac:grpSpMkLst>
+            <pc:docMk/>
+            <pc:sldMk cId="539501943" sldId="264"/>
+            <ac:grpSpMk id="3" creationId="{BB848F9C-B29C-ED0B-36A2-FDDCD264E10F}"/>
+          </ac:grpSpMkLst>
+        </pc:grpChg>
+        <pc:grpChg chg="add mod">
+          <ac:chgData name="Jonathan Bollig" userId="8b5d0afe-f106-45e0-8c3f-fd98fa124db1" providerId="ADAL" clId="{B2469FA9-EBD8-4834-A16D-CBF8EFC907DD}" dt="2025-10-07T22:34:48.750" v="5" actId="164"/>
+          <ac:grpSpMkLst>
+            <pc:docMk/>
+            <pc:sldMk cId="539501943" sldId="264"/>
+            <ac:grpSpMk id="10" creationId="{51435382-EBEE-BC7C-D2D6-759FCDB7C31B}"/>
+          </ac:grpSpMkLst>
+        </pc:grpChg>
+        <pc:cxnChg chg="mod">
+          <ac:chgData name="Jonathan Bollig" userId="8b5d0afe-f106-45e0-8c3f-fd98fa124db1" providerId="ADAL" clId="{B2469FA9-EBD8-4834-A16D-CBF8EFC907DD}" dt="2025-10-07T22:34:48.750" v="5" actId="164"/>
+          <ac:cxnSpMkLst>
+            <pc:docMk/>
+            <pc:sldMk cId="539501943" sldId="264"/>
+            <ac:cxnSpMk id="8" creationId="{7D51FF47-5803-1C53-B721-A38D4DC64796}"/>
+          </ac:cxnSpMkLst>
+        </pc:cxnChg>
+        <pc:cxnChg chg="mod">
+          <ac:chgData name="Jonathan Bollig" userId="8b5d0afe-f106-45e0-8c3f-fd98fa124db1" providerId="ADAL" clId="{B2469FA9-EBD8-4834-A16D-CBF8EFC907DD}" dt="2025-10-07T22:34:48.750" v="5" actId="164"/>
+          <ac:cxnSpMkLst>
+            <pc:docMk/>
+            <pc:sldMk cId="539501943" sldId="264"/>
+            <ac:cxnSpMk id="9" creationId="{B01B5AF8-366F-AAA8-9789-3F8776559E7B}"/>
+          </ac:cxnSpMkLst>
+        </pc:cxnChg>
+        <pc:cxnChg chg="mod">
+          <ac:chgData name="Jonathan Bollig" userId="8b5d0afe-f106-45e0-8c3f-fd98fa124db1" providerId="ADAL" clId="{B2469FA9-EBD8-4834-A16D-CBF8EFC907DD}" dt="2025-10-07T22:34:42.201" v="4" actId="164"/>
+          <ac:cxnSpMkLst>
+            <pc:docMk/>
+            <pc:sldMk cId="539501943" sldId="264"/>
+            <ac:cxnSpMk id="41" creationId="{FB304E74-A35A-56C0-5511-04E8A32B2F48}"/>
+          </ac:cxnSpMkLst>
+        </pc:cxnChg>
+        <pc:cxnChg chg="mod">
+          <ac:chgData name="Jonathan Bollig" userId="8b5d0afe-f106-45e0-8c3f-fd98fa124db1" providerId="ADAL" clId="{B2469FA9-EBD8-4834-A16D-CBF8EFC907DD}" dt="2025-10-07T22:34:42.201" v="4" actId="164"/>
+          <ac:cxnSpMkLst>
+            <pc:docMk/>
+            <pc:sldMk cId="539501943" sldId="264"/>
+            <ac:cxnSpMk id="42" creationId="{7789AECA-1B6E-32DA-D5C3-2BDB774E9336}"/>
+          </ac:cxnSpMkLst>
+        </pc:cxnChg>
+        <pc:cxnChg chg="mod">
+          <ac:chgData name="Jonathan Bollig" userId="8b5d0afe-f106-45e0-8c3f-fd98fa124db1" providerId="ADAL" clId="{B2469FA9-EBD8-4834-A16D-CBF8EFC907DD}" dt="2025-10-07T22:34:42.201" v="4" actId="164"/>
+          <ac:cxnSpMkLst>
+            <pc:docMk/>
+            <pc:sldMk cId="539501943" sldId="264"/>
+            <ac:cxnSpMk id="44" creationId="{B4F791B1-C516-74C1-410C-AC2A6EDD00E7}"/>
+          </ac:cxnSpMkLst>
+        </pc:cxnChg>
+      </pc:sldChg>
+      <pc:sldChg chg="modAnim">
+        <pc:chgData name="Jonathan Bollig" userId="8b5d0afe-f106-45e0-8c3f-fd98fa124db1" providerId="ADAL" clId="{B2469FA9-EBD8-4834-A16D-CBF8EFC907DD}" dt="2025-10-07T22:35:32.055" v="10"/>
+        <pc:sldMkLst>
+          <pc:docMk/>
+          <pc:sldMk cId="3053755417" sldId="265"/>
+        </pc:sldMkLst>
+      </pc:sldChg>
+      <pc:sldChg chg="modAnim">
+        <pc:chgData name="Jonathan Bollig" userId="8b5d0afe-f106-45e0-8c3f-fd98fa124db1" providerId="ADAL" clId="{B2469FA9-EBD8-4834-A16D-CBF8EFC907DD}" dt="2025-10-07T22:35:54.621" v="12"/>
+        <pc:sldMkLst>
+          <pc:docMk/>
+          <pc:sldMk cId="780551519" sldId="266"/>
+        </pc:sldMkLst>
+      </pc:sldChg>
+    </pc:docChg>
+  </pc:docChgLst>
+</pc:chgInfo>
+</file>
+
 <file path=ppt/notesMasters/notesMaster1.xml><?xml version="1.0" encoding="utf-8"?>
 <p:notesMaster xmlns:a="http://schemas.openxmlformats.org/drawingml/2006/main" xmlns:r="http://schemas.openxmlformats.org/officeDocument/2006/relationships" xmlns:p="http://schemas.openxmlformats.org/presentationml/2006/main">
   <p:cSld>
@@ -207,7 +449,7 @@
           <a:p>
             <a:fld id="{0B6CA2EE-5589-4682-AD7F-744DBF1E81F5}" type="datetimeFigureOut">
               <a:rPr lang="de-DE" smtClean="0"/>
-              <a:t>07.10.2025</a:t>
+              <a:t>08.10.2025</a:t>
             </a:fld>
             <a:endParaRPr lang="de-DE"/>
           </a:p>
@@ -365,7 +607,7 @@
           <a:p>
             <a:fld id="{11422C3B-6429-4381-8F08-B422F3CD22BF}" type="slidenum">
               <a:rPr lang="de-DE" smtClean="0"/>
-              <a:t>‹#›</a:t>
+              <a:t>‹Nr.›</a:t>
             </a:fld>
             <a:endParaRPr lang="de-DE"/>
           </a:p>
@@ -891,7 +1133,7 @@
           <a:p>
             <a:fld id="{ADA51F25-4808-47F4-BF6E-BCDC230DB01C}" type="datetimeFigureOut">
               <a:rPr lang="de-DE" smtClean="0"/>
-              <a:t>07.10.2025</a:t>
+              <a:t>08.10.2025</a:t>
             </a:fld>
             <a:endParaRPr lang="de-DE"/>
           </a:p>
@@ -945,7 +1187,7 @@
           <a:p>
             <a:fld id="{C018A060-D51C-4243-8F88-61D66D5570B8}" type="slidenum">
               <a:rPr lang="de-DE" smtClean="0"/>
-              <a:t>‹#›</a:t>
+              <a:t>‹Nr.›</a:t>
             </a:fld>
             <a:endParaRPr lang="de-DE"/>
           </a:p>
@@ -1089,7 +1331,7 @@
           <a:p>
             <a:fld id="{ADA51F25-4808-47F4-BF6E-BCDC230DB01C}" type="datetimeFigureOut">
               <a:rPr lang="de-DE" smtClean="0"/>
-              <a:t>07.10.2025</a:t>
+              <a:t>08.10.2025</a:t>
             </a:fld>
             <a:endParaRPr lang="de-DE"/>
           </a:p>
@@ -1143,7 +1385,7 @@
           <a:p>
             <a:fld id="{C018A060-D51C-4243-8F88-61D66D5570B8}" type="slidenum">
               <a:rPr lang="de-DE" smtClean="0"/>
-              <a:t>‹#›</a:t>
+              <a:t>‹Nr.›</a:t>
             </a:fld>
             <a:endParaRPr lang="de-DE"/>
           </a:p>
@@ -1297,7 +1539,7 @@
           <a:p>
             <a:fld id="{ADA51F25-4808-47F4-BF6E-BCDC230DB01C}" type="datetimeFigureOut">
               <a:rPr lang="de-DE" smtClean="0"/>
-              <a:t>07.10.2025</a:t>
+              <a:t>08.10.2025</a:t>
             </a:fld>
             <a:endParaRPr lang="de-DE"/>
           </a:p>
@@ -1351,7 +1593,7 @@
           <a:p>
             <a:fld id="{C018A060-D51C-4243-8F88-61D66D5570B8}" type="slidenum">
               <a:rPr lang="de-DE" smtClean="0"/>
-              <a:t>‹#›</a:t>
+              <a:t>‹Nr.›</a:t>
             </a:fld>
             <a:endParaRPr lang="de-DE"/>
           </a:p>
@@ -1495,7 +1737,7 @@
           <a:p>
             <a:fld id="{ADA51F25-4808-47F4-BF6E-BCDC230DB01C}" type="datetimeFigureOut">
               <a:rPr lang="de-DE" smtClean="0"/>
-              <a:t>07.10.2025</a:t>
+              <a:t>08.10.2025</a:t>
             </a:fld>
             <a:endParaRPr lang="de-DE"/>
           </a:p>
@@ -1549,7 +1791,7 @@
           <a:p>
             <a:fld id="{C018A060-D51C-4243-8F88-61D66D5570B8}" type="slidenum">
               <a:rPr lang="de-DE" smtClean="0"/>
-              <a:t>‹#›</a:t>
+              <a:t>‹Nr.›</a:t>
             </a:fld>
             <a:endParaRPr lang="de-DE"/>
           </a:p>
@@ -1770,7 +2012,7 @@
           <a:p>
             <a:fld id="{ADA51F25-4808-47F4-BF6E-BCDC230DB01C}" type="datetimeFigureOut">
               <a:rPr lang="de-DE" smtClean="0"/>
-              <a:t>07.10.2025</a:t>
+              <a:t>08.10.2025</a:t>
             </a:fld>
             <a:endParaRPr lang="de-DE"/>
           </a:p>
@@ -1824,7 +2066,7 @@
           <a:p>
             <a:fld id="{C018A060-D51C-4243-8F88-61D66D5570B8}" type="slidenum">
               <a:rPr lang="de-DE" smtClean="0"/>
-              <a:t>‹#›</a:t>
+              <a:t>‹Nr.›</a:t>
             </a:fld>
             <a:endParaRPr lang="de-DE"/>
           </a:p>
@@ -2035,7 +2277,7 @@
           <a:p>
             <a:fld id="{ADA51F25-4808-47F4-BF6E-BCDC230DB01C}" type="datetimeFigureOut">
               <a:rPr lang="de-DE" smtClean="0"/>
-              <a:t>07.10.2025</a:t>
+              <a:t>08.10.2025</a:t>
             </a:fld>
             <a:endParaRPr lang="de-DE"/>
           </a:p>
@@ -2089,7 +2331,7 @@
           <a:p>
             <a:fld id="{C018A060-D51C-4243-8F88-61D66D5570B8}" type="slidenum">
               <a:rPr lang="de-DE" smtClean="0"/>
-              <a:t>‹#›</a:t>
+              <a:t>‹Nr.›</a:t>
             </a:fld>
             <a:endParaRPr lang="de-DE"/>
           </a:p>
@@ -2447,7 +2689,7 @@
           <a:p>
             <a:fld id="{ADA51F25-4808-47F4-BF6E-BCDC230DB01C}" type="datetimeFigureOut">
               <a:rPr lang="de-DE" smtClean="0"/>
-              <a:t>07.10.2025</a:t>
+              <a:t>08.10.2025</a:t>
             </a:fld>
             <a:endParaRPr lang="de-DE"/>
           </a:p>
@@ -2501,7 +2743,7 @@
           <a:p>
             <a:fld id="{C018A060-D51C-4243-8F88-61D66D5570B8}" type="slidenum">
               <a:rPr lang="de-DE" smtClean="0"/>
-              <a:t>‹#›</a:t>
+              <a:t>‹Nr.›</a:t>
             </a:fld>
             <a:endParaRPr lang="de-DE"/>
           </a:p>
@@ -2588,7 +2830,7 @@
           <a:p>
             <a:fld id="{ADA51F25-4808-47F4-BF6E-BCDC230DB01C}" type="datetimeFigureOut">
               <a:rPr lang="de-DE" smtClean="0"/>
-              <a:t>07.10.2025</a:t>
+              <a:t>08.10.2025</a:t>
             </a:fld>
             <a:endParaRPr lang="de-DE"/>
           </a:p>
@@ -2642,7 +2884,7 @@
           <a:p>
             <a:fld id="{C018A060-D51C-4243-8F88-61D66D5570B8}" type="slidenum">
               <a:rPr lang="de-DE" smtClean="0"/>
-              <a:t>‹#›</a:t>
+              <a:t>‹Nr.›</a:t>
             </a:fld>
             <a:endParaRPr lang="de-DE"/>
           </a:p>
@@ -2701,7 +2943,7 @@
           <a:p>
             <a:fld id="{ADA51F25-4808-47F4-BF6E-BCDC230DB01C}" type="datetimeFigureOut">
               <a:rPr lang="de-DE" smtClean="0"/>
-              <a:t>07.10.2025</a:t>
+              <a:t>08.10.2025</a:t>
             </a:fld>
             <a:endParaRPr lang="de-DE"/>
           </a:p>
@@ -2755,7 +2997,7 @@
           <a:p>
             <a:fld id="{C018A060-D51C-4243-8F88-61D66D5570B8}" type="slidenum">
               <a:rPr lang="de-DE" smtClean="0"/>
-              <a:t>‹#›</a:t>
+              <a:t>‹Nr.›</a:t>
             </a:fld>
             <a:endParaRPr lang="de-DE"/>
           </a:p>
@@ -3012,7 +3254,7 @@
           <a:p>
             <a:fld id="{ADA51F25-4808-47F4-BF6E-BCDC230DB01C}" type="datetimeFigureOut">
               <a:rPr lang="de-DE" smtClean="0"/>
-              <a:t>07.10.2025</a:t>
+              <a:t>08.10.2025</a:t>
             </a:fld>
             <a:endParaRPr lang="de-DE"/>
           </a:p>
@@ -3066,7 +3308,7 @@
           <a:p>
             <a:fld id="{C018A060-D51C-4243-8F88-61D66D5570B8}" type="slidenum">
               <a:rPr lang="de-DE" smtClean="0"/>
-              <a:t>‹#›</a:t>
+              <a:t>‹Nr.›</a:t>
             </a:fld>
             <a:endParaRPr lang="de-DE"/>
           </a:p>
@@ -3300,7 +3542,7 @@
           <a:p>
             <a:fld id="{ADA51F25-4808-47F4-BF6E-BCDC230DB01C}" type="datetimeFigureOut">
               <a:rPr lang="de-DE" smtClean="0"/>
-              <a:t>07.10.2025</a:t>
+              <a:t>08.10.2025</a:t>
             </a:fld>
             <a:endParaRPr lang="de-DE"/>
           </a:p>
@@ -3354,7 +3596,7 @@
           <a:p>
             <a:fld id="{C018A060-D51C-4243-8F88-61D66D5570B8}" type="slidenum">
               <a:rPr lang="de-DE" smtClean="0"/>
-              <a:t>‹#›</a:t>
+              <a:t>‹Nr.›</a:t>
             </a:fld>
             <a:endParaRPr lang="de-DE"/>
           </a:p>
@@ -3541,7 +3783,7 @@
           <a:p>
             <a:fld id="{ADA51F25-4808-47F4-BF6E-BCDC230DB01C}" type="datetimeFigureOut">
               <a:rPr lang="de-DE" smtClean="0"/>
-              <a:t>07.10.2025</a:t>
+              <a:t>08.10.2025</a:t>
             </a:fld>
             <a:endParaRPr lang="de-DE"/>
           </a:p>
@@ -3631,7 +3873,7 @@
           <a:p>
             <a:fld id="{C018A060-D51C-4243-8F88-61D66D5570B8}" type="slidenum">
               <a:rPr lang="de-DE" smtClean="0"/>
-              <a:t>‹#›</a:t>
+              <a:t>‹Nr.›</a:t>
             </a:fld>
             <a:endParaRPr lang="de-DE"/>
           </a:p>
@@ -5040,154 +5282,175 @@
           </a:p>
         </p:txBody>
       </p:sp>
-      <p:pic>
-        <p:nvPicPr>
-          <p:cNvPr id="25" name="Grafik 24">
-            <a:extLst>
-              <a:ext uri="{FF2B5EF4-FFF2-40B4-BE49-F238E27FC236}">
-                <a16:creationId xmlns:a16="http://schemas.microsoft.com/office/drawing/2014/main" id="{DFCB6EC6-58E9-F445-8D98-BFE79365B557}"/>
-              </a:ext>
-            </a:extLst>
-          </p:cNvPr>
-          <p:cNvPicPr>
-            <a:picLocks noChangeAspect="1"/>
-          </p:cNvPicPr>
+      <p:grpSp>
+        <p:nvGrpSpPr>
+          <p:cNvPr id="10" name="Gruppieren 9">
+            <a:extLst>
+              <a:ext uri="{FF2B5EF4-FFF2-40B4-BE49-F238E27FC236}">
+                <a16:creationId xmlns:a16="http://schemas.microsoft.com/office/drawing/2014/main" id="{DBB487A3-BB4E-7B99-B021-53FFB4397574}"/>
+              </a:ext>
+            </a:extLst>
+          </p:cNvPr>
+          <p:cNvGrpSpPr/>
           <p:nvPr/>
-        </p:nvPicPr>
-        <p:blipFill>
-          <a:blip r:embed="rId2"/>
-          <a:stretch>
-            <a:fillRect/>
-          </a:stretch>
-        </p:blipFill>
-        <p:spPr>
+        </p:nvGrpSpPr>
+        <p:grpSpPr>
           <a:xfrm>
             <a:off x="1725426" y="3900829"/>
             <a:ext cx="2715855" cy="1939896"/>
+            <a:chOff x="1725426" y="3900829"/>
+            <a:chExt cx="2715855" cy="1939896"/>
           </a:xfrm>
-          <a:prstGeom prst="rect">
-            <a:avLst/>
-          </a:prstGeom>
-          <a:ln>
+        </p:grpSpPr>
+        <p:pic>
+          <p:nvPicPr>
+            <p:cNvPr id="25" name="Grafik 24">
+              <a:extLst>
+                <a:ext uri="{FF2B5EF4-FFF2-40B4-BE49-F238E27FC236}">
+                  <a16:creationId xmlns:a16="http://schemas.microsoft.com/office/drawing/2014/main" id="{DFCB6EC6-58E9-F445-8D98-BFE79365B557}"/>
+                </a:ext>
+              </a:extLst>
+            </p:cNvPr>
+            <p:cNvPicPr>
+              <a:picLocks noChangeAspect="1"/>
+            </p:cNvPicPr>
+            <p:nvPr/>
+          </p:nvPicPr>
+          <p:blipFill>
+            <a:blip r:embed="rId2"/>
+            <a:stretch>
+              <a:fillRect/>
+            </a:stretch>
+          </p:blipFill>
+          <p:spPr>
+            <a:xfrm>
+              <a:off x="1725426" y="3900829"/>
+              <a:ext cx="2715855" cy="1939896"/>
+            </a:xfrm>
+            <a:prstGeom prst="rect">
+              <a:avLst/>
+            </a:prstGeom>
+            <a:ln>
+              <a:noFill/>
+            </a:ln>
+            <a:effectLst>
+              <a:outerShdw blurRad="292100" dist="139700" dir="2700000" algn="tl" rotWithShape="0">
+                <a:srgbClr val="333333">
+                  <a:alpha val="65000"/>
+                </a:srgbClr>
+              </a:outerShdw>
+            </a:effectLst>
+          </p:spPr>
+        </p:pic>
+        <p:sp>
+          <p:nvSpPr>
+            <p:cNvPr id="26" name="Rechteck 25">
+              <a:extLst>
+                <a:ext uri="{FF2B5EF4-FFF2-40B4-BE49-F238E27FC236}">
+                  <a16:creationId xmlns:a16="http://schemas.microsoft.com/office/drawing/2014/main" id="{4B049117-E240-0C19-5590-9BED9B0BF43E}"/>
+                </a:ext>
+              </a:extLst>
+            </p:cNvPr>
+            <p:cNvSpPr/>
+            <p:nvPr/>
+          </p:nvSpPr>
+          <p:spPr>
+            <a:xfrm>
+              <a:off x="1831609" y="4971253"/>
+              <a:ext cx="663932" cy="354019"/>
+            </a:xfrm>
+            <a:prstGeom prst="rect">
+              <a:avLst/>
+            </a:prstGeom>
             <a:noFill/>
-          </a:ln>
-          <a:effectLst>
-            <a:outerShdw blurRad="292100" dist="139700" dir="2700000" algn="tl" rotWithShape="0">
-              <a:srgbClr val="333333">
-                <a:alpha val="65000"/>
-              </a:srgbClr>
-            </a:outerShdw>
-          </a:effectLst>
-        </p:spPr>
-      </p:pic>
-      <p:sp>
-        <p:nvSpPr>
-          <p:cNvPr id="26" name="Rechteck 25">
-            <a:extLst>
-              <a:ext uri="{FF2B5EF4-FFF2-40B4-BE49-F238E27FC236}">
-                <a16:creationId xmlns:a16="http://schemas.microsoft.com/office/drawing/2014/main" id="{4B049117-E240-0C19-5590-9BED9B0BF43E}"/>
-              </a:ext>
-            </a:extLst>
-          </p:cNvPr>
-          <p:cNvSpPr/>
-          <p:nvPr/>
-        </p:nvSpPr>
-        <p:spPr>
-          <a:xfrm>
-            <a:off x="1831609" y="4971253"/>
-            <a:ext cx="663932" cy="354019"/>
-          </a:xfrm>
-          <a:prstGeom prst="rect">
-            <a:avLst/>
-          </a:prstGeom>
-          <a:noFill/>
-          <a:ln w="57150" cap="flat" cmpd="sng" algn="ctr">
-            <a:solidFill>
-              <a:srgbClr val="FF0000"/>
-            </a:solidFill>
-            <a:prstDash val="solid"/>
-            <a:round/>
-            <a:headEnd type="none" w="med" len="med"/>
-            <a:tailEnd type="none" w="med" len="med"/>
-          </a:ln>
-        </p:spPr>
-        <p:style>
-          <a:lnRef idx="0">
-            <a:scrgbClr r="0" g="0" b="0"/>
-          </a:lnRef>
-          <a:fillRef idx="0">
-            <a:scrgbClr r="0" g="0" b="0"/>
-          </a:fillRef>
-          <a:effectRef idx="0">
-            <a:scrgbClr r="0" g="0" b="0"/>
-          </a:effectRef>
-          <a:fontRef idx="minor">
-            <a:schemeClr val="accent2"/>
-          </a:fontRef>
-        </p:style>
-        <p:txBody>
-          <a:bodyPr rtlCol="0" anchor="ctr"/>
-          <a:lstStyle/>
-          <a:p>
-            <a:pPr algn="ctr"/>
-            <a:endParaRPr lang="en-GB" noProof="0" dirty="0"/>
-          </a:p>
-        </p:txBody>
-      </p:sp>
-      <p:sp>
-        <p:nvSpPr>
-          <p:cNvPr id="27" name="Rechteck 26">
-            <a:extLst>
-              <a:ext uri="{FF2B5EF4-FFF2-40B4-BE49-F238E27FC236}">
-                <a16:creationId xmlns:a16="http://schemas.microsoft.com/office/drawing/2014/main" id="{134167D6-D2FE-01AF-B753-C0FC4968D4E7}"/>
-              </a:ext>
-            </a:extLst>
-          </p:cNvPr>
-          <p:cNvSpPr/>
-          <p:nvPr/>
-        </p:nvSpPr>
-        <p:spPr>
-          <a:xfrm>
-            <a:off x="3778179" y="4500898"/>
-            <a:ext cx="170823" cy="354019"/>
-          </a:xfrm>
-          <a:prstGeom prst="rect">
-            <a:avLst/>
-          </a:prstGeom>
-          <a:noFill/>
-          <a:ln w="57150" cap="flat" cmpd="sng" algn="ctr">
-            <a:solidFill>
-              <a:srgbClr val="FF0000"/>
-            </a:solidFill>
-            <a:prstDash val="solid"/>
-            <a:round/>
-            <a:headEnd type="none" w="med" len="med"/>
-            <a:tailEnd type="none" w="med" len="med"/>
-          </a:ln>
-        </p:spPr>
-        <p:style>
-          <a:lnRef idx="0">
-            <a:scrgbClr r="0" g="0" b="0"/>
-          </a:lnRef>
-          <a:fillRef idx="0">
-            <a:scrgbClr r="0" g="0" b="0"/>
-          </a:fillRef>
-          <a:effectRef idx="0">
-            <a:scrgbClr r="0" g="0" b="0"/>
-          </a:effectRef>
-          <a:fontRef idx="minor">
-            <a:schemeClr val="accent2"/>
-          </a:fontRef>
-        </p:style>
-        <p:txBody>
-          <a:bodyPr rtlCol="0" anchor="ctr"/>
-          <a:lstStyle/>
-          <a:p>
-            <a:pPr algn="ctr"/>
-            <a:endParaRPr lang="en-GB" noProof="0" dirty="0"/>
-          </a:p>
-        </p:txBody>
-      </p:sp>
+            <a:ln w="57150" cap="flat" cmpd="sng" algn="ctr">
+              <a:solidFill>
+                <a:srgbClr val="FF0000"/>
+              </a:solidFill>
+              <a:prstDash val="solid"/>
+              <a:round/>
+              <a:headEnd type="none" w="med" len="med"/>
+              <a:tailEnd type="none" w="med" len="med"/>
+            </a:ln>
+          </p:spPr>
+          <p:style>
+            <a:lnRef idx="0">
+              <a:scrgbClr r="0" g="0" b="0"/>
+            </a:lnRef>
+            <a:fillRef idx="0">
+              <a:scrgbClr r="0" g="0" b="0"/>
+            </a:fillRef>
+            <a:effectRef idx="0">
+              <a:scrgbClr r="0" g="0" b="0"/>
+            </a:effectRef>
+            <a:fontRef idx="minor">
+              <a:schemeClr val="accent2"/>
+            </a:fontRef>
+          </p:style>
+          <p:txBody>
+            <a:bodyPr rtlCol="0" anchor="ctr"/>
+            <a:lstStyle/>
+            <a:p>
+              <a:pPr algn="ctr"/>
+              <a:endParaRPr lang="en-GB" noProof="0" dirty="0"/>
+            </a:p>
+          </p:txBody>
+        </p:sp>
+        <p:sp>
+          <p:nvSpPr>
+            <p:cNvPr id="27" name="Rechteck 26">
+              <a:extLst>
+                <a:ext uri="{FF2B5EF4-FFF2-40B4-BE49-F238E27FC236}">
+                  <a16:creationId xmlns:a16="http://schemas.microsoft.com/office/drawing/2014/main" id="{134167D6-D2FE-01AF-B753-C0FC4968D4E7}"/>
+                </a:ext>
+              </a:extLst>
+            </p:cNvPr>
+            <p:cNvSpPr/>
+            <p:nvPr/>
+          </p:nvSpPr>
+          <p:spPr>
+            <a:xfrm>
+              <a:off x="3778179" y="4500898"/>
+              <a:ext cx="170823" cy="354019"/>
+            </a:xfrm>
+            <a:prstGeom prst="rect">
+              <a:avLst/>
+            </a:prstGeom>
+            <a:noFill/>
+            <a:ln w="57150" cap="flat" cmpd="sng" algn="ctr">
+              <a:solidFill>
+                <a:srgbClr val="FF0000"/>
+              </a:solidFill>
+              <a:prstDash val="solid"/>
+              <a:round/>
+              <a:headEnd type="none" w="med" len="med"/>
+              <a:tailEnd type="none" w="med" len="med"/>
+            </a:ln>
+          </p:spPr>
+          <p:style>
+            <a:lnRef idx="0">
+              <a:scrgbClr r="0" g="0" b="0"/>
+            </a:lnRef>
+            <a:fillRef idx="0">
+              <a:scrgbClr r="0" g="0" b="0"/>
+            </a:fillRef>
+            <a:effectRef idx="0">
+              <a:scrgbClr r="0" g="0" b="0"/>
+            </a:effectRef>
+            <a:fontRef idx="minor">
+              <a:schemeClr val="accent2"/>
+            </a:fontRef>
+          </p:style>
+          <p:txBody>
+            <a:bodyPr rtlCol="0" anchor="ctr"/>
+            <a:lstStyle/>
+            <a:p>
+              <a:pPr algn="ctr"/>
+              <a:endParaRPr lang="en-GB" noProof="0" dirty="0"/>
+            </a:p>
+          </p:txBody>
+        </p:sp>
+      </p:grpSp>
     </p:spTree>
     <p:extLst>
       <p:ext uri="{BB962C8B-B14F-4D97-AF65-F5344CB8AC3E}">
@@ -5198,6 +5461,81 @@
   <p:clrMapOvr>
     <a:masterClrMapping/>
   </p:clrMapOvr>
+  <p:timing>
+    <p:tnLst>
+      <p:par>
+        <p:cTn id="1" dur="indefinite" restart="never" nodeType="tmRoot">
+          <p:childTnLst>
+            <p:seq concurrent="1" nextAc="seek">
+              <p:cTn id="2" dur="indefinite" nodeType="mainSeq">
+                <p:childTnLst>
+                  <p:par>
+                    <p:cTn id="3" fill="hold">
+                      <p:stCondLst>
+                        <p:cond delay="indefinite"/>
+                      </p:stCondLst>
+                      <p:childTnLst>
+                        <p:par>
+                          <p:cTn id="4" fill="hold">
+                            <p:stCondLst>
+                              <p:cond delay="0"/>
+                            </p:stCondLst>
+                            <p:childTnLst>
+                              <p:par>
+                                <p:cTn id="5" presetID="1" presetClass="entr" presetSubtype="0" fill="hold" nodeType="clickEffect">
+                                  <p:stCondLst>
+                                    <p:cond delay="0"/>
+                                  </p:stCondLst>
+                                  <p:childTnLst>
+                                    <p:set>
+                                      <p:cBhvr>
+                                        <p:cTn id="6" dur="1" fill="hold">
+                                          <p:stCondLst>
+                                            <p:cond delay="0"/>
+                                          </p:stCondLst>
+                                        </p:cTn>
+                                        <p:tgtEl>
+                                          <p:spTgt spid="10"/>
+                                        </p:tgtEl>
+                                        <p:attrNameLst>
+                                          <p:attrName>style.visibility</p:attrName>
+                                        </p:attrNameLst>
+                                      </p:cBhvr>
+                                      <p:to>
+                                        <p:strVal val="visible"/>
+                                      </p:to>
+                                    </p:set>
+                                  </p:childTnLst>
+                                </p:cTn>
+                              </p:par>
+                            </p:childTnLst>
+                          </p:cTn>
+                        </p:par>
+                      </p:childTnLst>
+                    </p:cTn>
+                  </p:par>
+                </p:childTnLst>
+              </p:cTn>
+              <p:prevCondLst>
+                <p:cond evt="onPrev" delay="0">
+                  <p:tgtEl>
+                    <p:sldTgt/>
+                  </p:tgtEl>
+                </p:cond>
+              </p:prevCondLst>
+              <p:nextCondLst>
+                <p:cond evt="onNext" delay="0">
+                  <p:tgtEl>
+                    <p:sldTgt/>
+                  </p:tgtEl>
+                </p:cond>
+              </p:nextCondLst>
+            </p:seq>
+          </p:childTnLst>
+        </p:cTn>
+      </p:par>
+    </p:tnLst>
+  </p:timing>
 </p:sld>
 </file>
 
@@ -7063,1083 +7401,1125 @@
           </a:p>
         </p:txBody>
       </p:sp>
-      <p:sp>
-        <p:nvSpPr>
-          <p:cNvPr id="4" name="Rechteck: abgerundete Ecken 3">
-            <a:extLst>
-              <a:ext uri="{FF2B5EF4-FFF2-40B4-BE49-F238E27FC236}">
-                <a16:creationId xmlns:a16="http://schemas.microsoft.com/office/drawing/2014/main" id="{4FCF54D6-4A6D-35CE-6FC9-39D50CE85FF2}"/>
-              </a:ext>
-            </a:extLst>
-          </p:cNvPr>
-          <p:cNvSpPr/>
+      <p:grpSp>
+        <p:nvGrpSpPr>
+          <p:cNvPr id="10" name="Gruppieren 9">
+            <a:extLst>
+              <a:ext uri="{FF2B5EF4-FFF2-40B4-BE49-F238E27FC236}">
+                <a16:creationId xmlns:a16="http://schemas.microsoft.com/office/drawing/2014/main" id="{51435382-EBEE-BC7C-D2D6-759FCDB7C31B}"/>
+              </a:ext>
+            </a:extLst>
+          </p:cNvPr>
+          <p:cNvGrpSpPr/>
           <p:nvPr/>
-        </p:nvSpPr>
-        <p:spPr>
+        </p:nvGrpSpPr>
+        <p:grpSpPr>
           <a:xfrm>
-            <a:off x="7377023" y="1861255"/>
-            <a:ext cx="2733427" cy="841248"/>
+            <a:off x="6261622" y="634351"/>
+            <a:ext cx="5808256" cy="5475450"/>
+            <a:chOff x="6261622" y="634351"/>
+            <a:chExt cx="5808256" cy="5475450"/>
           </a:xfrm>
-          <a:prstGeom prst="roundRect">
-            <a:avLst/>
-          </a:prstGeom>
-          <a:solidFill>
-            <a:srgbClr val="FFFFCC"/>
-          </a:solidFill>
-        </p:spPr>
-        <p:style>
-          <a:lnRef idx="2">
-            <a:schemeClr val="accent1">
-              <a:shade val="15000"/>
-            </a:schemeClr>
-          </a:lnRef>
-          <a:fillRef idx="1">
-            <a:schemeClr val="accent1"/>
-          </a:fillRef>
-          <a:effectRef idx="0">
-            <a:schemeClr val="accent1"/>
-          </a:effectRef>
-          <a:fontRef idx="minor">
-            <a:schemeClr val="lt1"/>
-          </a:fontRef>
-        </p:style>
-        <p:txBody>
-          <a:bodyPr rtlCol="0" anchor="ctr"/>
-          <a:lstStyle/>
-          <a:p>
-            <a:pPr algn="ctr"/>
-            <a:r>
-              <a:rPr lang="en-GB" dirty="0">
+        </p:grpSpPr>
+        <p:sp>
+          <p:nvSpPr>
+            <p:cNvPr id="4" name="Rechteck: abgerundete Ecken 3">
+              <a:extLst>
+                <a:ext uri="{FF2B5EF4-FFF2-40B4-BE49-F238E27FC236}">
+                  <a16:creationId xmlns:a16="http://schemas.microsoft.com/office/drawing/2014/main" id="{4FCF54D6-4A6D-35CE-6FC9-39D50CE85FF2}"/>
+                </a:ext>
+              </a:extLst>
+            </p:cNvPr>
+            <p:cNvSpPr/>
+            <p:nvPr/>
+          </p:nvSpPr>
+          <p:spPr>
+            <a:xfrm>
+              <a:off x="7377023" y="1861255"/>
+              <a:ext cx="2733427" cy="841248"/>
+            </a:xfrm>
+            <a:prstGeom prst="roundRect">
+              <a:avLst/>
+            </a:prstGeom>
+            <a:solidFill>
+              <a:srgbClr val="FFFFCC"/>
+            </a:solidFill>
+          </p:spPr>
+          <p:style>
+            <a:lnRef idx="2">
+              <a:schemeClr val="accent1">
+                <a:shade val="15000"/>
+              </a:schemeClr>
+            </a:lnRef>
+            <a:fillRef idx="1">
+              <a:schemeClr val="accent1"/>
+            </a:fillRef>
+            <a:effectRef idx="0">
+              <a:schemeClr val="accent1"/>
+            </a:effectRef>
+            <a:fontRef idx="minor">
+              <a:schemeClr val="lt1"/>
+            </a:fontRef>
+          </p:style>
+          <p:txBody>
+            <a:bodyPr rtlCol="0" anchor="ctr"/>
+            <a:lstStyle/>
+            <a:p>
+              <a:pPr algn="ctr"/>
+              <a:r>
+                <a:rPr lang="en-GB" dirty="0">
+                  <a:solidFill>
+                    <a:schemeClr val="tx1"/>
+                  </a:solidFill>
+                </a:rPr>
+                <a:t>if - Condition</a:t>
+              </a:r>
+              <a:endParaRPr lang="en-GB" noProof="0" dirty="0">
                 <a:solidFill>
                   <a:schemeClr val="tx1"/>
                 </a:solidFill>
-              </a:rPr>
-              <a:t>if - Condition</a:t>
-            </a:r>
-            <a:endParaRPr lang="en-GB" noProof="0" dirty="0">
+              </a:endParaRPr>
+            </a:p>
+          </p:txBody>
+        </p:sp>
+        <p:sp>
+          <p:nvSpPr>
+            <p:cNvPr id="5" name="Rechteck: abgerundete Ecken 4">
+              <a:extLst>
+                <a:ext uri="{FF2B5EF4-FFF2-40B4-BE49-F238E27FC236}">
+                  <a16:creationId xmlns:a16="http://schemas.microsoft.com/office/drawing/2014/main" id="{0F270356-AFF2-A7FA-15E6-E6C505BCC5C9}"/>
+                </a:ext>
+              </a:extLst>
+            </p:cNvPr>
+            <p:cNvSpPr/>
+            <p:nvPr/>
+          </p:nvSpPr>
+          <p:spPr>
+            <a:xfrm>
+              <a:off x="9336451" y="3687546"/>
+              <a:ext cx="2733427" cy="841248"/>
+            </a:xfrm>
+            <a:prstGeom prst="roundRect">
+              <a:avLst/>
+            </a:prstGeom>
+            <a:solidFill>
+              <a:srgbClr val="FFFFCC"/>
+            </a:solidFill>
+          </p:spPr>
+          <p:style>
+            <a:lnRef idx="2">
+              <a:schemeClr val="accent1">
+                <a:shade val="15000"/>
+              </a:schemeClr>
+            </a:lnRef>
+            <a:fillRef idx="1">
+              <a:schemeClr val="accent1"/>
+            </a:fillRef>
+            <a:effectRef idx="0">
+              <a:schemeClr val="accent1"/>
+            </a:effectRef>
+            <a:fontRef idx="minor">
+              <a:schemeClr val="lt1"/>
+            </a:fontRef>
+          </p:style>
+          <p:txBody>
+            <a:bodyPr rtlCol="0" anchor="ctr"/>
+            <a:lstStyle/>
+            <a:p>
+              <a:pPr algn="ctr"/>
+              <a:r>
+                <a:rPr lang="en-GB" noProof="0" dirty="0">
+                  <a:solidFill>
+                    <a:schemeClr val="tx1"/>
+                  </a:solidFill>
+                </a:rPr>
+                <a:t>Code</a:t>
+              </a:r>
+            </a:p>
+          </p:txBody>
+        </p:sp>
+        <p:sp>
+          <p:nvSpPr>
+            <p:cNvPr id="6" name="Rechteck: abgerundete Ecken 5">
+              <a:extLst>
+                <a:ext uri="{FF2B5EF4-FFF2-40B4-BE49-F238E27FC236}">
+                  <a16:creationId xmlns:a16="http://schemas.microsoft.com/office/drawing/2014/main" id="{80648EA6-2644-D128-38C0-3C28778A272B}"/>
+                </a:ext>
+              </a:extLst>
+            </p:cNvPr>
+            <p:cNvSpPr/>
+            <p:nvPr/>
+          </p:nvSpPr>
+          <p:spPr>
+            <a:xfrm>
+              <a:off x="7377022" y="634351"/>
+              <a:ext cx="2733427" cy="841248"/>
+            </a:xfrm>
+            <a:prstGeom prst="roundRect">
+              <a:avLst/>
+            </a:prstGeom>
+            <a:solidFill>
+              <a:srgbClr val="FFFFCC"/>
+            </a:solidFill>
+          </p:spPr>
+          <p:style>
+            <a:lnRef idx="2">
+              <a:schemeClr val="accent1">
+                <a:shade val="15000"/>
+              </a:schemeClr>
+            </a:lnRef>
+            <a:fillRef idx="1">
+              <a:schemeClr val="accent1"/>
+            </a:fillRef>
+            <a:effectRef idx="0">
+              <a:schemeClr val="accent1"/>
+            </a:effectRef>
+            <a:fontRef idx="minor">
+              <a:schemeClr val="lt1"/>
+            </a:fontRef>
+          </p:style>
+          <p:txBody>
+            <a:bodyPr rtlCol="0" anchor="ctr"/>
+            <a:lstStyle/>
+            <a:p>
+              <a:pPr algn="ctr"/>
+              <a:r>
+                <a:rPr lang="en-GB" noProof="0" dirty="0">
+                  <a:solidFill>
+                    <a:schemeClr val="tx1"/>
+                  </a:solidFill>
+                </a:rPr>
+                <a:t>Code</a:t>
+              </a:r>
+            </a:p>
+          </p:txBody>
+        </p:sp>
+        <p:sp>
+          <p:nvSpPr>
+            <p:cNvPr id="7" name="Rechteck: abgerundete Ecken 6">
+              <a:extLst>
+                <a:ext uri="{FF2B5EF4-FFF2-40B4-BE49-F238E27FC236}">
+                  <a16:creationId xmlns:a16="http://schemas.microsoft.com/office/drawing/2014/main" id="{7D63D7FB-DAFA-DF99-F517-9119FC1AC9C0}"/>
+                </a:ext>
+              </a:extLst>
+            </p:cNvPr>
+            <p:cNvSpPr/>
+            <p:nvPr/>
+          </p:nvSpPr>
+          <p:spPr>
+            <a:xfrm>
+              <a:off x="7377022" y="5268553"/>
+              <a:ext cx="2733427" cy="841248"/>
+            </a:xfrm>
+            <a:prstGeom prst="roundRect">
+              <a:avLst/>
+            </a:prstGeom>
+            <a:solidFill>
+              <a:srgbClr val="FFFFCC"/>
+            </a:solidFill>
+          </p:spPr>
+          <p:style>
+            <a:lnRef idx="2">
+              <a:schemeClr val="accent1">
+                <a:shade val="15000"/>
+              </a:schemeClr>
+            </a:lnRef>
+            <a:fillRef idx="1">
+              <a:schemeClr val="accent1"/>
+            </a:fillRef>
+            <a:effectRef idx="0">
+              <a:schemeClr val="accent1"/>
+            </a:effectRef>
+            <a:fontRef idx="minor">
+              <a:schemeClr val="lt1"/>
+            </a:fontRef>
+          </p:style>
+          <p:txBody>
+            <a:bodyPr rtlCol="0" anchor="ctr"/>
+            <a:lstStyle/>
+            <a:p>
+              <a:pPr algn="ctr"/>
+              <a:r>
+                <a:rPr lang="en-GB" noProof="0" dirty="0">
+                  <a:solidFill>
+                    <a:schemeClr val="tx1"/>
+                  </a:solidFill>
+                </a:rPr>
+                <a:t>Code</a:t>
+              </a:r>
+            </a:p>
+          </p:txBody>
+        </p:sp>
+        <p:cxnSp>
+          <p:nvCxnSpPr>
+            <p:cNvPr id="8" name="Gerade Verbindung mit Pfeil 7">
+              <a:extLst>
+                <a:ext uri="{FF2B5EF4-FFF2-40B4-BE49-F238E27FC236}">
+                  <a16:creationId xmlns:a16="http://schemas.microsoft.com/office/drawing/2014/main" id="{7D51FF47-5803-1C53-B721-A38D4DC64796}"/>
+                </a:ext>
+              </a:extLst>
+            </p:cNvPr>
+            <p:cNvCxnSpPr>
+              <a:cxnSpLocks/>
+              <a:stCxn id="4" idx="2"/>
+              <a:endCxn id="5" idx="0"/>
+            </p:cNvCxnSpPr>
+            <p:nvPr/>
+          </p:nvCxnSpPr>
+          <p:spPr>
+            <a:xfrm>
+              <a:off x="8743737" y="2702503"/>
+              <a:ext cx="1959428" cy="985043"/>
+            </a:xfrm>
+            <a:prstGeom prst="straightConnector1">
+              <a:avLst/>
+            </a:prstGeom>
+            <a:ln>
+              <a:headEnd type="none" w="med" len="med"/>
+              <a:tailEnd type="arrow" w="med" len="med"/>
+            </a:ln>
+          </p:spPr>
+          <p:style>
+            <a:lnRef idx="3">
+              <a:schemeClr val="dk1"/>
+            </a:lnRef>
+            <a:fillRef idx="0">
+              <a:schemeClr val="dk1"/>
+            </a:fillRef>
+            <a:effectRef idx="2">
+              <a:schemeClr val="dk1"/>
+            </a:effectRef>
+            <a:fontRef idx="minor">
+              <a:schemeClr val="tx1"/>
+            </a:fontRef>
+          </p:style>
+        </p:cxnSp>
+        <p:cxnSp>
+          <p:nvCxnSpPr>
+            <p:cNvPr id="9" name="Gerade Verbindung mit Pfeil 8">
+              <a:extLst>
+                <a:ext uri="{FF2B5EF4-FFF2-40B4-BE49-F238E27FC236}">
+                  <a16:creationId xmlns:a16="http://schemas.microsoft.com/office/drawing/2014/main" id="{B01B5AF8-366F-AAA8-9789-3F8776559E7B}"/>
+                </a:ext>
+              </a:extLst>
+            </p:cNvPr>
+            <p:cNvCxnSpPr>
+              <a:cxnSpLocks/>
+              <a:stCxn id="6" idx="2"/>
+              <a:endCxn id="4" idx="0"/>
+            </p:cNvCxnSpPr>
+            <p:nvPr/>
+          </p:nvCxnSpPr>
+          <p:spPr>
+            <a:xfrm>
+              <a:off x="8743736" y="1475599"/>
+              <a:ext cx="1" cy="385656"/>
+            </a:xfrm>
+            <a:prstGeom prst="straightConnector1">
+              <a:avLst/>
+            </a:prstGeom>
+            <a:ln>
+              <a:headEnd type="none" w="med" len="med"/>
+              <a:tailEnd type="arrow" w="med" len="med"/>
+            </a:ln>
+          </p:spPr>
+          <p:style>
+            <a:lnRef idx="3">
+              <a:schemeClr val="dk1"/>
+            </a:lnRef>
+            <a:fillRef idx="0">
+              <a:schemeClr val="dk1"/>
+            </a:fillRef>
+            <a:effectRef idx="2">
+              <a:schemeClr val="dk1"/>
+            </a:effectRef>
+            <a:fontRef idx="minor">
+              <a:schemeClr val="tx1"/>
+            </a:fontRef>
+          </p:style>
+        </p:cxnSp>
+        <p:cxnSp>
+          <p:nvCxnSpPr>
+            <p:cNvPr id="11" name="Gerade Verbindung mit Pfeil 10">
+              <a:extLst>
+                <a:ext uri="{FF2B5EF4-FFF2-40B4-BE49-F238E27FC236}">
+                  <a16:creationId xmlns:a16="http://schemas.microsoft.com/office/drawing/2014/main" id="{FCEE2C36-EE25-7320-061B-B70BBD04A72F}"/>
+                </a:ext>
+              </a:extLst>
+            </p:cNvPr>
+            <p:cNvCxnSpPr>
+              <a:cxnSpLocks/>
+              <a:stCxn id="5" idx="2"/>
+              <a:endCxn id="7" idx="0"/>
+            </p:cNvCxnSpPr>
+            <p:nvPr/>
+          </p:nvCxnSpPr>
+          <p:spPr>
+            <a:xfrm flipH="1">
+              <a:off x="8743736" y="4528794"/>
+              <a:ext cx="1959429" cy="739759"/>
+            </a:xfrm>
+            <a:prstGeom prst="straightConnector1">
+              <a:avLst/>
+            </a:prstGeom>
+            <a:ln>
+              <a:headEnd type="none" w="med" len="med"/>
+              <a:tailEnd type="arrow" w="med" len="med"/>
+            </a:ln>
+          </p:spPr>
+          <p:style>
+            <a:lnRef idx="3">
+              <a:schemeClr val="dk1"/>
+            </a:lnRef>
+            <a:fillRef idx="0">
+              <a:schemeClr val="dk1"/>
+            </a:fillRef>
+            <a:effectRef idx="2">
+              <a:schemeClr val="dk1"/>
+            </a:effectRef>
+            <a:fontRef idx="minor">
+              <a:schemeClr val="tx1"/>
+            </a:fontRef>
+          </p:style>
+        </p:cxnSp>
+        <p:sp>
+          <p:nvSpPr>
+            <p:cNvPr id="12" name="Textfeld 11">
+              <a:extLst>
+                <a:ext uri="{FF2B5EF4-FFF2-40B4-BE49-F238E27FC236}">
+                  <a16:creationId xmlns:a16="http://schemas.microsoft.com/office/drawing/2014/main" id="{0F4CBEE2-754A-BF38-DB4B-DC6A6F16BD1E}"/>
+                </a:ext>
+              </a:extLst>
+            </p:cNvPr>
+            <p:cNvSpPr txBox="1"/>
+            <p:nvPr/>
+          </p:nvSpPr>
+          <p:spPr>
+            <a:xfrm>
+              <a:off x="9459815" y="3037476"/>
+              <a:ext cx="650634" cy="369332"/>
+            </a:xfrm>
+            <a:prstGeom prst="rect">
+              <a:avLst/>
+            </a:prstGeom>
+            <a:solidFill>
+              <a:schemeClr val="bg1"/>
+            </a:solidFill>
+            <a:ln>
               <a:solidFill>
                 <a:schemeClr val="tx1"/>
               </a:solidFill>
-            </a:endParaRPr>
-          </a:p>
-        </p:txBody>
-      </p:sp>
-      <p:sp>
-        <p:nvSpPr>
-          <p:cNvPr id="5" name="Rechteck: abgerundete Ecken 4">
-            <a:extLst>
-              <a:ext uri="{FF2B5EF4-FFF2-40B4-BE49-F238E27FC236}">
-                <a16:creationId xmlns:a16="http://schemas.microsoft.com/office/drawing/2014/main" id="{0F270356-AFF2-A7FA-15E6-E6C505BCC5C9}"/>
-              </a:ext>
-            </a:extLst>
-          </p:cNvPr>
-          <p:cNvSpPr/>
+            </a:ln>
+          </p:spPr>
+          <p:txBody>
+            <a:bodyPr wrap="square" rtlCol="0">
+              <a:spAutoFit/>
+            </a:bodyPr>
+            <a:lstStyle/>
+            <a:p>
+              <a:r>
+                <a:rPr lang="en-US" dirty="0"/>
+                <a:t>True</a:t>
+              </a:r>
+              <a:endParaRPr lang="de-DE" dirty="0"/>
+            </a:p>
+          </p:txBody>
+        </p:sp>
+        <p:cxnSp>
+          <p:nvCxnSpPr>
+            <p:cNvPr id="14" name="Gerade Verbindung mit Pfeil 13">
+              <a:extLst>
+                <a:ext uri="{FF2B5EF4-FFF2-40B4-BE49-F238E27FC236}">
+                  <a16:creationId xmlns:a16="http://schemas.microsoft.com/office/drawing/2014/main" id="{A2C90197-45DD-988D-728C-EB6B040A52DF}"/>
+                </a:ext>
+              </a:extLst>
+            </p:cNvPr>
+            <p:cNvCxnSpPr>
+              <a:cxnSpLocks/>
+              <a:endCxn id="16" idx="0"/>
+            </p:cNvCxnSpPr>
+            <p:nvPr/>
+          </p:nvCxnSpPr>
+          <p:spPr>
+            <a:xfrm flipH="1">
+              <a:off x="7628336" y="2702503"/>
+              <a:ext cx="1115399" cy="946306"/>
+            </a:xfrm>
+            <a:prstGeom prst="straightConnector1">
+              <a:avLst/>
+            </a:prstGeom>
+            <a:ln>
+              <a:headEnd type="none" w="med" len="med"/>
+              <a:tailEnd type="arrow" w="med" len="med"/>
+            </a:ln>
+          </p:spPr>
+          <p:style>
+            <a:lnRef idx="3">
+              <a:schemeClr val="dk1"/>
+            </a:lnRef>
+            <a:fillRef idx="0">
+              <a:schemeClr val="dk1"/>
+            </a:fillRef>
+            <a:effectRef idx="2">
+              <a:schemeClr val="dk1"/>
+            </a:effectRef>
+            <a:fontRef idx="minor">
+              <a:schemeClr val="tx1"/>
+            </a:fontRef>
+          </p:style>
+        </p:cxnSp>
+        <p:cxnSp>
+          <p:nvCxnSpPr>
+            <p:cNvPr id="15" name="Gerade Verbindung mit Pfeil 14">
+              <a:extLst>
+                <a:ext uri="{FF2B5EF4-FFF2-40B4-BE49-F238E27FC236}">
+                  <a16:creationId xmlns:a16="http://schemas.microsoft.com/office/drawing/2014/main" id="{41564787-C89B-6E46-E4B4-4056A16D65AD}"/>
+                </a:ext>
+              </a:extLst>
+            </p:cNvPr>
+            <p:cNvCxnSpPr>
+              <a:cxnSpLocks/>
+            </p:cNvCxnSpPr>
+            <p:nvPr/>
+          </p:nvCxnSpPr>
+          <p:spPr>
+            <a:xfrm>
+              <a:off x="7628336" y="4528794"/>
+              <a:ext cx="1195247" cy="739759"/>
+            </a:xfrm>
+            <a:prstGeom prst="straightConnector1">
+              <a:avLst/>
+            </a:prstGeom>
+            <a:ln>
+              <a:headEnd type="none" w="med" len="med"/>
+              <a:tailEnd type="arrow" w="med" len="med"/>
+            </a:ln>
+          </p:spPr>
+          <p:style>
+            <a:lnRef idx="3">
+              <a:schemeClr val="dk1"/>
+            </a:lnRef>
+            <a:fillRef idx="0">
+              <a:schemeClr val="dk1"/>
+            </a:fillRef>
+            <a:effectRef idx="2">
+              <a:schemeClr val="dk1"/>
+            </a:effectRef>
+            <a:fontRef idx="minor">
+              <a:schemeClr val="tx1"/>
+            </a:fontRef>
+          </p:style>
+        </p:cxnSp>
+        <p:sp>
+          <p:nvSpPr>
+            <p:cNvPr id="16" name="Rechteck: abgerundete Ecken 15">
+              <a:extLst>
+                <a:ext uri="{FF2B5EF4-FFF2-40B4-BE49-F238E27FC236}">
+                  <a16:creationId xmlns:a16="http://schemas.microsoft.com/office/drawing/2014/main" id="{F1DBB668-4150-1DE3-13CE-53CC70D585A6}"/>
+                </a:ext>
+              </a:extLst>
+            </p:cNvPr>
+            <p:cNvSpPr/>
+            <p:nvPr/>
+          </p:nvSpPr>
+          <p:spPr>
+            <a:xfrm>
+              <a:off x="6261622" y="3648809"/>
+              <a:ext cx="2733427" cy="841248"/>
+            </a:xfrm>
+            <a:prstGeom prst="roundRect">
+              <a:avLst/>
+            </a:prstGeom>
+            <a:solidFill>
+              <a:srgbClr val="FFFFCC"/>
+            </a:solidFill>
+          </p:spPr>
+          <p:style>
+            <a:lnRef idx="2">
+              <a:schemeClr val="accent1">
+                <a:shade val="15000"/>
+              </a:schemeClr>
+            </a:lnRef>
+            <a:fillRef idx="1">
+              <a:schemeClr val="accent1"/>
+            </a:fillRef>
+            <a:effectRef idx="0">
+              <a:schemeClr val="accent1"/>
+            </a:effectRef>
+            <a:fontRef idx="minor">
+              <a:schemeClr val="lt1"/>
+            </a:fontRef>
+          </p:style>
+          <p:txBody>
+            <a:bodyPr rtlCol="0" anchor="ctr"/>
+            <a:lstStyle/>
+            <a:p>
+              <a:pPr algn="ctr"/>
+              <a:r>
+                <a:rPr lang="en-GB" noProof="0" dirty="0">
+                  <a:solidFill>
+                    <a:schemeClr val="tx1"/>
+                  </a:solidFill>
+                </a:rPr>
+                <a:t>Code</a:t>
+              </a:r>
+            </a:p>
+          </p:txBody>
+        </p:sp>
+        <p:sp>
+          <p:nvSpPr>
+            <p:cNvPr id="13" name="Textfeld 12">
+              <a:extLst>
+                <a:ext uri="{FF2B5EF4-FFF2-40B4-BE49-F238E27FC236}">
+                  <a16:creationId xmlns:a16="http://schemas.microsoft.com/office/drawing/2014/main" id="{6C12A045-772B-0FBE-AC43-41C8BBD9E99B}"/>
+                </a:ext>
+              </a:extLst>
+            </p:cNvPr>
+            <p:cNvSpPr txBox="1"/>
+            <p:nvPr/>
+          </p:nvSpPr>
+          <p:spPr>
+            <a:xfrm>
+              <a:off x="7798707" y="3012984"/>
+              <a:ext cx="774656" cy="369332"/>
+            </a:xfrm>
+            <a:prstGeom prst="rect">
+              <a:avLst/>
+            </a:prstGeom>
+            <a:solidFill>
+              <a:schemeClr val="bg1"/>
+            </a:solidFill>
+            <a:ln>
+              <a:solidFill>
+                <a:schemeClr val="tx1"/>
+              </a:solidFill>
+            </a:ln>
+          </p:spPr>
+          <p:txBody>
+            <a:bodyPr wrap="square" rtlCol="0">
+              <a:spAutoFit/>
+            </a:bodyPr>
+            <a:lstStyle/>
+            <a:p>
+              <a:r>
+                <a:rPr lang="en-US" dirty="0"/>
+                <a:t>False</a:t>
+              </a:r>
+              <a:endParaRPr lang="de-DE" dirty="0"/>
+            </a:p>
+          </p:txBody>
+        </p:sp>
+      </p:grpSp>
+      <p:grpSp>
+        <p:nvGrpSpPr>
+          <p:cNvPr id="3" name="Gruppieren 2">
+            <a:extLst>
+              <a:ext uri="{FF2B5EF4-FFF2-40B4-BE49-F238E27FC236}">
+                <a16:creationId xmlns:a16="http://schemas.microsoft.com/office/drawing/2014/main" id="{BB848F9C-B29C-ED0B-36A2-FDDCD264E10F}"/>
+              </a:ext>
+            </a:extLst>
+          </p:cNvPr>
+          <p:cNvGrpSpPr/>
           <p:nvPr/>
-        </p:nvSpPr>
-        <p:spPr>
+        </p:nvGrpSpPr>
+        <p:grpSpPr>
           <a:xfrm>
-            <a:off x="9336451" y="3687546"/>
-            <a:ext cx="2733427" cy="841248"/>
+            <a:off x="130424" y="634351"/>
+            <a:ext cx="4592373" cy="5475450"/>
+            <a:chOff x="130424" y="634351"/>
+            <a:chExt cx="4592373" cy="5475450"/>
           </a:xfrm>
-          <a:prstGeom prst="roundRect">
-            <a:avLst/>
-          </a:prstGeom>
-          <a:solidFill>
-            <a:srgbClr val="FFFFCC"/>
-          </a:solidFill>
-        </p:spPr>
-        <p:style>
-          <a:lnRef idx="2">
-            <a:schemeClr val="accent1">
-              <a:shade val="15000"/>
-            </a:schemeClr>
-          </a:lnRef>
-          <a:fillRef idx="1">
-            <a:schemeClr val="accent1"/>
-          </a:fillRef>
-          <a:effectRef idx="0">
-            <a:schemeClr val="accent1"/>
-          </a:effectRef>
-          <a:fontRef idx="minor">
-            <a:schemeClr val="lt1"/>
-          </a:fontRef>
-        </p:style>
-        <p:txBody>
-          <a:bodyPr rtlCol="0" anchor="ctr"/>
-          <a:lstStyle/>
-          <a:p>
-            <a:pPr algn="ctr"/>
-            <a:r>
-              <a:rPr lang="en-GB" noProof="0" dirty="0">
+        </p:grpSpPr>
+        <p:sp>
+          <p:nvSpPr>
+            <p:cNvPr id="37" name="Rechteck: abgerundete Ecken 36">
+              <a:extLst>
+                <a:ext uri="{FF2B5EF4-FFF2-40B4-BE49-F238E27FC236}">
+                  <a16:creationId xmlns:a16="http://schemas.microsoft.com/office/drawing/2014/main" id="{E63E1191-2AD7-F354-BD40-5C33059EB9DE}"/>
+                </a:ext>
+              </a:extLst>
+            </p:cNvPr>
+            <p:cNvSpPr/>
+            <p:nvPr/>
+          </p:nvSpPr>
+          <p:spPr>
+            <a:xfrm>
+              <a:off x="130425" y="1861255"/>
+              <a:ext cx="2733427" cy="841248"/>
+            </a:xfrm>
+            <a:prstGeom prst="roundRect">
+              <a:avLst/>
+            </a:prstGeom>
+            <a:solidFill>
+              <a:srgbClr val="FFFFCC"/>
+            </a:solidFill>
+          </p:spPr>
+          <p:style>
+            <a:lnRef idx="2">
+              <a:schemeClr val="accent1">
+                <a:shade val="15000"/>
+              </a:schemeClr>
+            </a:lnRef>
+            <a:fillRef idx="1">
+              <a:schemeClr val="accent1"/>
+            </a:fillRef>
+            <a:effectRef idx="0">
+              <a:schemeClr val="accent1"/>
+            </a:effectRef>
+            <a:fontRef idx="minor">
+              <a:schemeClr val="lt1"/>
+            </a:fontRef>
+          </p:style>
+          <p:txBody>
+            <a:bodyPr rtlCol="0" anchor="ctr"/>
+            <a:lstStyle/>
+            <a:p>
+              <a:pPr algn="ctr"/>
+              <a:r>
+                <a:rPr lang="en-GB" dirty="0">
+                  <a:solidFill>
+                    <a:schemeClr val="tx1"/>
+                  </a:solidFill>
+                </a:rPr>
+                <a:t>if - Condition</a:t>
+              </a:r>
+              <a:endParaRPr lang="en-GB" noProof="0" dirty="0">
                 <a:solidFill>
                   <a:schemeClr val="tx1"/>
                 </a:solidFill>
-              </a:rPr>
-              <a:t>Code</a:t>
-            </a:r>
-          </a:p>
-        </p:txBody>
-      </p:sp>
-      <p:sp>
-        <p:nvSpPr>
-          <p:cNvPr id="6" name="Rechteck: abgerundete Ecken 5">
-            <a:extLst>
-              <a:ext uri="{FF2B5EF4-FFF2-40B4-BE49-F238E27FC236}">
-                <a16:creationId xmlns:a16="http://schemas.microsoft.com/office/drawing/2014/main" id="{80648EA6-2644-D128-38C0-3C28778A272B}"/>
-              </a:ext>
-            </a:extLst>
-          </p:cNvPr>
-          <p:cNvSpPr/>
-          <p:nvPr/>
-        </p:nvSpPr>
-        <p:spPr>
-          <a:xfrm>
-            <a:off x="7377022" y="634351"/>
-            <a:ext cx="2733427" cy="841248"/>
-          </a:xfrm>
-          <a:prstGeom prst="roundRect">
-            <a:avLst/>
-          </a:prstGeom>
-          <a:solidFill>
-            <a:srgbClr val="FFFFCC"/>
-          </a:solidFill>
-        </p:spPr>
-        <p:style>
-          <a:lnRef idx="2">
-            <a:schemeClr val="accent1">
-              <a:shade val="15000"/>
-            </a:schemeClr>
-          </a:lnRef>
-          <a:fillRef idx="1">
-            <a:schemeClr val="accent1"/>
-          </a:fillRef>
-          <a:effectRef idx="0">
-            <a:schemeClr val="accent1"/>
-          </a:effectRef>
-          <a:fontRef idx="minor">
-            <a:schemeClr val="lt1"/>
-          </a:fontRef>
-        </p:style>
-        <p:txBody>
-          <a:bodyPr rtlCol="0" anchor="ctr"/>
-          <a:lstStyle/>
-          <a:p>
-            <a:pPr algn="ctr"/>
-            <a:r>
-              <a:rPr lang="en-GB" noProof="0" dirty="0">
-                <a:solidFill>
-                  <a:schemeClr val="tx1"/>
-                </a:solidFill>
-              </a:rPr>
-              <a:t>Code</a:t>
-            </a:r>
-          </a:p>
-        </p:txBody>
-      </p:sp>
-      <p:sp>
-        <p:nvSpPr>
-          <p:cNvPr id="7" name="Rechteck: abgerundete Ecken 6">
-            <a:extLst>
-              <a:ext uri="{FF2B5EF4-FFF2-40B4-BE49-F238E27FC236}">
-                <a16:creationId xmlns:a16="http://schemas.microsoft.com/office/drawing/2014/main" id="{7D63D7FB-DAFA-DF99-F517-9119FC1AC9C0}"/>
-              </a:ext>
-            </a:extLst>
-          </p:cNvPr>
-          <p:cNvSpPr/>
-          <p:nvPr/>
-        </p:nvSpPr>
-        <p:spPr>
-          <a:xfrm>
-            <a:off x="7377022" y="5268553"/>
-            <a:ext cx="2733427" cy="841248"/>
-          </a:xfrm>
-          <a:prstGeom prst="roundRect">
-            <a:avLst/>
-          </a:prstGeom>
-          <a:solidFill>
-            <a:srgbClr val="FFFFCC"/>
-          </a:solidFill>
-        </p:spPr>
-        <p:style>
-          <a:lnRef idx="2">
-            <a:schemeClr val="accent1">
-              <a:shade val="15000"/>
-            </a:schemeClr>
-          </a:lnRef>
-          <a:fillRef idx="1">
-            <a:schemeClr val="accent1"/>
-          </a:fillRef>
-          <a:effectRef idx="0">
-            <a:schemeClr val="accent1"/>
-          </a:effectRef>
-          <a:fontRef idx="minor">
-            <a:schemeClr val="lt1"/>
-          </a:fontRef>
-        </p:style>
-        <p:txBody>
-          <a:bodyPr rtlCol="0" anchor="ctr"/>
-          <a:lstStyle/>
-          <a:p>
-            <a:pPr algn="ctr"/>
-            <a:r>
-              <a:rPr lang="en-GB" noProof="0" dirty="0">
-                <a:solidFill>
-                  <a:schemeClr val="tx1"/>
-                </a:solidFill>
-              </a:rPr>
-              <a:t>Code</a:t>
-            </a:r>
-          </a:p>
-        </p:txBody>
-      </p:sp>
-      <p:cxnSp>
-        <p:nvCxnSpPr>
-          <p:cNvPr id="8" name="Gerade Verbindung mit Pfeil 7">
-            <a:extLst>
-              <a:ext uri="{FF2B5EF4-FFF2-40B4-BE49-F238E27FC236}">
-                <a16:creationId xmlns:a16="http://schemas.microsoft.com/office/drawing/2014/main" id="{7D51FF47-5803-1C53-B721-A38D4DC64796}"/>
-              </a:ext>
-            </a:extLst>
-          </p:cNvPr>
-          <p:cNvCxnSpPr>
-            <a:cxnSpLocks/>
-            <a:stCxn id="4" idx="2"/>
-            <a:endCxn id="5" idx="0"/>
-          </p:cNvCxnSpPr>
-          <p:nvPr/>
-        </p:nvCxnSpPr>
-        <p:spPr>
-          <a:xfrm>
-            <a:off x="8743737" y="2702503"/>
-            <a:ext cx="1959428" cy="985043"/>
-          </a:xfrm>
-          <a:prstGeom prst="straightConnector1">
-            <a:avLst/>
-          </a:prstGeom>
-          <a:ln>
-            <a:headEnd type="none" w="med" len="med"/>
-            <a:tailEnd type="arrow" w="med" len="med"/>
-          </a:ln>
-        </p:spPr>
-        <p:style>
-          <a:lnRef idx="3">
-            <a:schemeClr val="dk1"/>
-          </a:lnRef>
-          <a:fillRef idx="0">
-            <a:schemeClr val="dk1"/>
-          </a:fillRef>
-          <a:effectRef idx="2">
-            <a:schemeClr val="dk1"/>
-          </a:effectRef>
-          <a:fontRef idx="minor">
-            <a:schemeClr val="tx1"/>
-          </a:fontRef>
-        </p:style>
-      </p:cxnSp>
-      <p:cxnSp>
-        <p:nvCxnSpPr>
-          <p:cNvPr id="9" name="Gerade Verbindung mit Pfeil 8">
-            <a:extLst>
-              <a:ext uri="{FF2B5EF4-FFF2-40B4-BE49-F238E27FC236}">
-                <a16:creationId xmlns:a16="http://schemas.microsoft.com/office/drawing/2014/main" id="{B01B5AF8-366F-AAA8-9789-3F8776559E7B}"/>
-              </a:ext>
-            </a:extLst>
-          </p:cNvPr>
-          <p:cNvCxnSpPr>
-            <a:cxnSpLocks/>
-            <a:stCxn id="6" idx="2"/>
-            <a:endCxn id="4" idx="0"/>
-          </p:cNvCxnSpPr>
-          <p:nvPr/>
-        </p:nvCxnSpPr>
-        <p:spPr>
-          <a:xfrm>
-            <a:off x="8743736" y="1475599"/>
-            <a:ext cx="1" cy="385656"/>
-          </a:xfrm>
-          <a:prstGeom prst="straightConnector1">
-            <a:avLst/>
-          </a:prstGeom>
-          <a:ln>
-            <a:headEnd type="none" w="med" len="med"/>
-            <a:tailEnd type="arrow" w="med" len="med"/>
-          </a:ln>
-        </p:spPr>
-        <p:style>
-          <a:lnRef idx="3">
-            <a:schemeClr val="dk1"/>
-          </a:lnRef>
-          <a:fillRef idx="0">
-            <a:schemeClr val="dk1"/>
-          </a:fillRef>
-          <a:effectRef idx="2">
-            <a:schemeClr val="dk1"/>
-          </a:effectRef>
-          <a:fontRef idx="minor">
-            <a:schemeClr val="tx1"/>
-          </a:fontRef>
-        </p:style>
-      </p:cxnSp>
-      <p:cxnSp>
-        <p:nvCxnSpPr>
-          <p:cNvPr id="11" name="Gerade Verbindung mit Pfeil 10">
-            <a:extLst>
-              <a:ext uri="{FF2B5EF4-FFF2-40B4-BE49-F238E27FC236}">
-                <a16:creationId xmlns:a16="http://schemas.microsoft.com/office/drawing/2014/main" id="{FCEE2C36-EE25-7320-061B-B70BBD04A72F}"/>
-              </a:ext>
-            </a:extLst>
-          </p:cNvPr>
-          <p:cNvCxnSpPr>
-            <a:cxnSpLocks/>
-            <a:stCxn id="5" idx="2"/>
-            <a:endCxn id="7" idx="0"/>
-          </p:cNvCxnSpPr>
-          <p:nvPr/>
-        </p:nvCxnSpPr>
-        <p:spPr>
-          <a:xfrm flipH="1">
-            <a:off x="8743736" y="4528794"/>
-            <a:ext cx="1959429" cy="739759"/>
-          </a:xfrm>
-          <a:prstGeom prst="straightConnector1">
-            <a:avLst/>
-          </a:prstGeom>
-          <a:ln>
-            <a:headEnd type="none" w="med" len="med"/>
-            <a:tailEnd type="arrow" w="med" len="med"/>
-          </a:ln>
-        </p:spPr>
-        <p:style>
-          <a:lnRef idx="3">
-            <a:schemeClr val="dk1"/>
-          </a:lnRef>
-          <a:fillRef idx="0">
-            <a:schemeClr val="dk1"/>
-          </a:fillRef>
-          <a:effectRef idx="2">
-            <a:schemeClr val="dk1"/>
-          </a:effectRef>
-          <a:fontRef idx="minor">
-            <a:schemeClr val="tx1"/>
-          </a:fontRef>
-        </p:style>
-      </p:cxnSp>
-      <p:sp>
-        <p:nvSpPr>
-          <p:cNvPr id="12" name="Textfeld 11">
-            <a:extLst>
-              <a:ext uri="{FF2B5EF4-FFF2-40B4-BE49-F238E27FC236}">
-                <a16:creationId xmlns:a16="http://schemas.microsoft.com/office/drawing/2014/main" id="{0F4CBEE2-754A-BF38-DB4B-DC6A6F16BD1E}"/>
-              </a:ext>
-            </a:extLst>
-          </p:cNvPr>
-          <p:cNvSpPr txBox="1"/>
-          <p:nvPr/>
-        </p:nvSpPr>
-        <p:spPr>
-          <a:xfrm>
-            <a:off x="9459815" y="3037476"/>
-            <a:ext cx="650634" cy="369332"/>
-          </a:xfrm>
-          <a:prstGeom prst="rect">
-            <a:avLst/>
-          </a:prstGeom>
-          <a:solidFill>
-            <a:schemeClr val="bg1"/>
-          </a:solidFill>
-          <a:ln>
+              </a:endParaRPr>
+            </a:p>
+          </p:txBody>
+        </p:sp>
+        <p:sp>
+          <p:nvSpPr>
+            <p:cNvPr id="38" name="Rechteck: abgerundete Ecken 37">
+              <a:extLst>
+                <a:ext uri="{FF2B5EF4-FFF2-40B4-BE49-F238E27FC236}">
+                  <a16:creationId xmlns:a16="http://schemas.microsoft.com/office/drawing/2014/main" id="{9F45DB8C-28F2-F23D-79DC-3A8BA3E30F61}"/>
+                </a:ext>
+              </a:extLst>
+            </p:cNvPr>
+            <p:cNvSpPr/>
+            <p:nvPr/>
+          </p:nvSpPr>
+          <p:spPr>
+            <a:xfrm>
+              <a:off x="1989370" y="3687546"/>
+              <a:ext cx="2733427" cy="841248"/>
+            </a:xfrm>
+            <a:prstGeom prst="roundRect">
+              <a:avLst/>
+            </a:prstGeom>
             <a:solidFill>
+              <a:srgbClr val="FFFFCC"/>
+            </a:solidFill>
+          </p:spPr>
+          <p:style>
+            <a:lnRef idx="2">
+              <a:schemeClr val="accent1">
+                <a:shade val="15000"/>
+              </a:schemeClr>
+            </a:lnRef>
+            <a:fillRef idx="1">
+              <a:schemeClr val="accent1"/>
+            </a:fillRef>
+            <a:effectRef idx="0">
+              <a:schemeClr val="accent1"/>
+            </a:effectRef>
+            <a:fontRef idx="minor">
+              <a:schemeClr val="lt1"/>
+            </a:fontRef>
+          </p:style>
+          <p:txBody>
+            <a:bodyPr rtlCol="0" anchor="ctr"/>
+            <a:lstStyle/>
+            <a:p>
+              <a:pPr algn="ctr"/>
+              <a:r>
+                <a:rPr lang="en-GB" noProof="0" dirty="0">
+                  <a:solidFill>
+                    <a:schemeClr val="tx1"/>
+                  </a:solidFill>
+                </a:rPr>
+                <a:t>Code</a:t>
+              </a:r>
+            </a:p>
+          </p:txBody>
+        </p:sp>
+        <p:sp>
+          <p:nvSpPr>
+            <p:cNvPr id="39" name="Rechteck: abgerundete Ecken 38">
+              <a:extLst>
+                <a:ext uri="{FF2B5EF4-FFF2-40B4-BE49-F238E27FC236}">
+                  <a16:creationId xmlns:a16="http://schemas.microsoft.com/office/drawing/2014/main" id="{CCCAAA7C-4625-CAE3-40BE-A672B37E9FDF}"/>
+                </a:ext>
+              </a:extLst>
+            </p:cNvPr>
+            <p:cNvSpPr/>
+            <p:nvPr/>
+          </p:nvSpPr>
+          <p:spPr>
+            <a:xfrm>
+              <a:off x="130424" y="634351"/>
+              <a:ext cx="2733427" cy="841248"/>
+            </a:xfrm>
+            <a:prstGeom prst="roundRect">
+              <a:avLst/>
+            </a:prstGeom>
+            <a:solidFill>
+              <a:srgbClr val="FFFFCC"/>
+            </a:solidFill>
+          </p:spPr>
+          <p:style>
+            <a:lnRef idx="2">
+              <a:schemeClr val="accent1">
+                <a:shade val="15000"/>
+              </a:schemeClr>
+            </a:lnRef>
+            <a:fillRef idx="1">
+              <a:schemeClr val="accent1"/>
+            </a:fillRef>
+            <a:effectRef idx="0">
+              <a:schemeClr val="accent1"/>
+            </a:effectRef>
+            <a:fontRef idx="minor">
+              <a:schemeClr val="lt1"/>
+            </a:fontRef>
+          </p:style>
+          <p:txBody>
+            <a:bodyPr rtlCol="0" anchor="ctr"/>
+            <a:lstStyle/>
+            <a:p>
+              <a:pPr algn="ctr"/>
+              <a:r>
+                <a:rPr lang="en-GB" noProof="0" dirty="0">
+                  <a:solidFill>
+                    <a:schemeClr val="tx1"/>
+                  </a:solidFill>
+                </a:rPr>
+                <a:t>Code</a:t>
+              </a:r>
+            </a:p>
+          </p:txBody>
+        </p:sp>
+        <p:sp>
+          <p:nvSpPr>
+            <p:cNvPr id="40" name="Rechteck: abgerundete Ecken 39">
+              <a:extLst>
+                <a:ext uri="{FF2B5EF4-FFF2-40B4-BE49-F238E27FC236}">
+                  <a16:creationId xmlns:a16="http://schemas.microsoft.com/office/drawing/2014/main" id="{E868DF51-CBF5-34F3-2FB6-F47074E84AB7}"/>
+                </a:ext>
+              </a:extLst>
+            </p:cNvPr>
+            <p:cNvSpPr/>
+            <p:nvPr/>
+          </p:nvSpPr>
+          <p:spPr>
+            <a:xfrm>
+              <a:off x="130424" y="5268553"/>
+              <a:ext cx="2733427" cy="841248"/>
+            </a:xfrm>
+            <a:prstGeom prst="roundRect">
+              <a:avLst/>
+            </a:prstGeom>
+            <a:solidFill>
+              <a:srgbClr val="FFFFCC"/>
+            </a:solidFill>
+          </p:spPr>
+          <p:style>
+            <a:lnRef idx="2">
+              <a:schemeClr val="accent1">
+                <a:shade val="15000"/>
+              </a:schemeClr>
+            </a:lnRef>
+            <a:fillRef idx="1">
+              <a:schemeClr val="accent1"/>
+            </a:fillRef>
+            <a:effectRef idx="0">
+              <a:schemeClr val="accent1"/>
+            </a:effectRef>
+            <a:fontRef idx="minor">
+              <a:schemeClr val="lt1"/>
+            </a:fontRef>
+          </p:style>
+          <p:txBody>
+            <a:bodyPr rtlCol="0" anchor="ctr"/>
+            <a:lstStyle/>
+            <a:p>
+              <a:pPr algn="ctr"/>
+              <a:r>
+                <a:rPr lang="en-GB" noProof="0" dirty="0">
+                  <a:solidFill>
+                    <a:schemeClr val="tx1"/>
+                  </a:solidFill>
+                </a:rPr>
+                <a:t>Code</a:t>
+              </a:r>
+            </a:p>
+          </p:txBody>
+        </p:sp>
+        <p:cxnSp>
+          <p:nvCxnSpPr>
+            <p:cNvPr id="41" name="Gerade Verbindung mit Pfeil 40">
+              <a:extLst>
+                <a:ext uri="{FF2B5EF4-FFF2-40B4-BE49-F238E27FC236}">
+                  <a16:creationId xmlns:a16="http://schemas.microsoft.com/office/drawing/2014/main" id="{FB304E74-A35A-56C0-5511-04E8A32B2F48}"/>
+                </a:ext>
+              </a:extLst>
+            </p:cNvPr>
+            <p:cNvCxnSpPr>
+              <a:cxnSpLocks/>
+              <a:stCxn id="37" idx="2"/>
+              <a:endCxn id="38" idx="0"/>
+            </p:cNvCxnSpPr>
+            <p:nvPr/>
+          </p:nvCxnSpPr>
+          <p:spPr>
+            <a:xfrm>
+              <a:off x="1497139" y="2702503"/>
+              <a:ext cx="1858945" cy="985043"/>
+            </a:xfrm>
+            <a:prstGeom prst="straightConnector1">
+              <a:avLst/>
+            </a:prstGeom>
+            <a:ln>
+              <a:headEnd type="none" w="med" len="med"/>
+              <a:tailEnd type="arrow" w="med" len="med"/>
+            </a:ln>
+          </p:spPr>
+          <p:style>
+            <a:lnRef idx="3">
+              <a:schemeClr val="dk1"/>
+            </a:lnRef>
+            <a:fillRef idx="0">
+              <a:schemeClr val="dk1"/>
+            </a:fillRef>
+            <a:effectRef idx="2">
+              <a:schemeClr val="dk1"/>
+            </a:effectRef>
+            <a:fontRef idx="minor">
               <a:schemeClr val="tx1"/>
+            </a:fontRef>
+          </p:style>
+        </p:cxnSp>
+        <p:cxnSp>
+          <p:nvCxnSpPr>
+            <p:cNvPr id="42" name="Gerade Verbindung mit Pfeil 41">
+              <a:extLst>
+                <a:ext uri="{FF2B5EF4-FFF2-40B4-BE49-F238E27FC236}">
+                  <a16:creationId xmlns:a16="http://schemas.microsoft.com/office/drawing/2014/main" id="{7789AECA-1B6E-32DA-D5C3-2BDB774E9336}"/>
+                </a:ext>
+              </a:extLst>
+            </p:cNvPr>
+            <p:cNvCxnSpPr>
+              <a:cxnSpLocks/>
+              <a:stCxn id="39" idx="2"/>
+              <a:endCxn id="37" idx="0"/>
+            </p:cNvCxnSpPr>
+            <p:nvPr/>
+          </p:nvCxnSpPr>
+          <p:spPr>
+            <a:xfrm>
+              <a:off x="1497138" y="1475599"/>
+              <a:ext cx="1" cy="385656"/>
+            </a:xfrm>
+            <a:prstGeom prst="straightConnector1">
+              <a:avLst/>
+            </a:prstGeom>
+            <a:ln>
+              <a:headEnd type="none" w="med" len="med"/>
+              <a:tailEnd type="arrow" w="med" len="med"/>
+            </a:ln>
+          </p:spPr>
+          <p:style>
+            <a:lnRef idx="3">
+              <a:schemeClr val="dk1"/>
+            </a:lnRef>
+            <a:fillRef idx="0">
+              <a:schemeClr val="dk1"/>
+            </a:fillRef>
+            <a:effectRef idx="2">
+              <a:schemeClr val="dk1"/>
+            </a:effectRef>
+            <a:fontRef idx="minor">
+              <a:schemeClr val="tx1"/>
+            </a:fontRef>
+          </p:style>
+        </p:cxnSp>
+        <p:cxnSp>
+          <p:nvCxnSpPr>
+            <p:cNvPr id="43" name="Gerade Verbindung mit Pfeil 42">
+              <a:extLst>
+                <a:ext uri="{FF2B5EF4-FFF2-40B4-BE49-F238E27FC236}">
+                  <a16:creationId xmlns:a16="http://schemas.microsoft.com/office/drawing/2014/main" id="{4A3E2242-7152-1103-701F-279C6B56229B}"/>
+                </a:ext>
+              </a:extLst>
+            </p:cNvPr>
+            <p:cNvCxnSpPr>
+              <a:cxnSpLocks/>
+              <a:stCxn id="37" idx="2"/>
+              <a:endCxn id="40" idx="0"/>
+            </p:cNvCxnSpPr>
+            <p:nvPr/>
+          </p:nvCxnSpPr>
+          <p:spPr>
+            <a:xfrm flipH="1">
+              <a:off x="1497138" y="2702503"/>
+              <a:ext cx="1" cy="2566050"/>
+            </a:xfrm>
+            <a:prstGeom prst="straightConnector1">
+              <a:avLst/>
+            </a:prstGeom>
+            <a:ln>
+              <a:headEnd type="none" w="med" len="med"/>
+              <a:tailEnd type="arrow" w="med" len="med"/>
+            </a:ln>
+          </p:spPr>
+          <p:style>
+            <a:lnRef idx="3">
+              <a:schemeClr val="dk1"/>
+            </a:lnRef>
+            <a:fillRef idx="0">
+              <a:schemeClr val="dk1"/>
+            </a:fillRef>
+            <a:effectRef idx="2">
+              <a:schemeClr val="dk1"/>
+            </a:effectRef>
+            <a:fontRef idx="minor">
+              <a:schemeClr val="tx1"/>
+            </a:fontRef>
+          </p:style>
+        </p:cxnSp>
+        <p:cxnSp>
+          <p:nvCxnSpPr>
+            <p:cNvPr id="44" name="Gerade Verbindung mit Pfeil 43">
+              <a:extLst>
+                <a:ext uri="{FF2B5EF4-FFF2-40B4-BE49-F238E27FC236}">
+                  <a16:creationId xmlns:a16="http://schemas.microsoft.com/office/drawing/2014/main" id="{B4F791B1-C516-74C1-410C-AC2A6EDD00E7}"/>
+                </a:ext>
+              </a:extLst>
+            </p:cNvPr>
+            <p:cNvCxnSpPr>
+              <a:cxnSpLocks/>
+            </p:cNvCxnSpPr>
+            <p:nvPr/>
+          </p:nvCxnSpPr>
+          <p:spPr>
+            <a:xfrm flipH="1">
+              <a:off x="1497138" y="4528794"/>
+              <a:ext cx="1858946" cy="739759"/>
+            </a:xfrm>
+            <a:prstGeom prst="straightConnector1">
+              <a:avLst/>
+            </a:prstGeom>
+            <a:ln>
+              <a:headEnd type="none" w="med" len="med"/>
+              <a:tailEnd type="arrow" w="med" len="med"/>
+            </a:ln>
+          </p:spPr>
+          <p:style>
+            <a:lnRef idx="3">
+              <a:schemeClr val="dk1"/>
+            </a:lnRef>
+            <a:fillRef idx="0">
+              <a:schemeClr val="dk1"/>
+            </a:fillRef>
+            <a:effectRef idx="2">
+              <a:schemeClr val="dk1"/>
+            </a:effectRef>
+            <a:fontRef idx="minor">
+              <a:schemeClr val="tx1"/>
+            </a:fontRef>
+          </p:style>
+        </p:cxnSp>
+        <p:sp>
+          <p:nvSpPr>
+            <p:cNvPr id="45" name="Textfeld 44">
+              <a:extLst>
+                <a:ext uri="{FF2B5EF4-FFF2-40B4-BE49-F238E27FC236}">
+                  <a16:creationId xmlns:a16="http://schemas.microsoft.com/office/drawing/2014/main" id="{4F2C637F-8D54-8E10-2820-74622DED5FB7}"/>
+                </a:ext>
+              </a:extLst>
+            </p:cNvPr>
+            <p:cNvSpPr txBox="1"/>
+            <p:nvPr/>
+          </p:nvSpPr>
+          <p:spPr>
+            <a:xfrm>
+              <a:off x="2213217" y="3037476"/>
+              <a:ext cx="650634" cy="369332"/>
+            </a:xfrm>
+            <a:prstGeom prst="rect">
+              <a:avLst/>
+            </a:prstGeom>
+            <a:solidFill>
+              <a:schemeClr val="bg1"/>
             </a:solidFill>
-          </a:ln>
-        </p:spPr>
-        <p:txBody>
-          <a:bodyPr wrap="square" rtlCol="0">
-            <a:spAutoFit/>
-          </a:bodyPr>
-          <a:lstStyle/>
-          <a:p>
-            <a:r>
-              <a:rPr lang="en-US" dirty="0"/>
-              <a:t>True</a:t>
-            </a:r>
-            <a:endParaRPr lang="de-DE" dirty="0"/>
-          </a:p>
-        </p:txBody>
-      </p:sp>
-      <p:cxnSp>
-        <p:nvCxnSpPr>
-          <p:cNvPr id="14" name="Gerade Verbindung mit Pfeil 13">
-            <a:extLst>
-              <a:ext uri="{FF2B5EF4-FFF2-40B4-BE49-F238E27FC236}">
-                <a16:creationId xmlns:a16="http://schemas.microsoft.com/office/drawing/2014/main" id="{A2C90197-45DD-988D-728C-EB6B040A52DF}"/>
-              </a:ext>
-            </a:extLst>
-          </p:cNvPr>
-          <p:cNvCxnSpPr>
-            <a:cxnSpLocks/>
-            <a:endCxn id="16" idx="0"/>
-          </p:cNvCxnSpPr>
-          <p:nvPr/>
-        </p:nvCxnSpPr>
-        <p:spPr>
-          <a:xfrm flipH="1">
-            <a:off x="7628336" y="2702503"/>
-            <a:ext cx="1115399" cy="946306"/>
-          </a:xfrm>
-          <a:prstGeom prst="straightConnector1">
-            <a:avLst/>
-          </a:prstGeom>
-          <a:ln>
-            <a:headEnd type="none" w="med" len="med"/>
-            <a:tailEnd type="arrow" w="med" len="med"/>
-          </a:ln>
-        </p:spPr>
-        <p:style>
-          <a:lnRef idx="3">
-            <a:schemeClr val="dk1"/>
-          </a:lnRef>
-          <a:fillRef idx="0">
-            <a:schemeClr val="dk1"/>
-          </a:fillRef>
-          <a:effectRef idx="2">
-            <a:schemeClr val="dk1"/>
-          </a:effectRef>
-          <a:fontRef idx="minor">
-            <a:schemeClr val="tx1"/>
-          </a:fontRef>
-        </p:style>
-      </p:cxnSp>
-      <p:cxnSp>
-        <p:nvCxnSpPr>
-          <p:cNvPr id="15" name="Gerade Verbindung mit Pfeil 14">
-            <a:extLst>
-              <a:ext uri="{FF2B5EF4-FFF2-40B4-BE49-F238E27FC236}">
-                <a16:creationId xmlns:a16="http://schemas.microsoft.com/office/drawing/2014/main" id="{41564787-C89B-6E46-E4B4-4056A16D65AD}"/>
-              </a:ext>
-            </a:extLst>
-          </p:cNvPr>
-          <p:cNvCxnSpPr>
-            <a:cxnSpLocks/>
-          </p:cNvCxnSpPr>
-          <p:nvPr/>
-        </p:nvCxnSpPr>
-        <p:spPr>
-          <a:xfrm>
-            <a:off x="7628336" y="4528794"/>
-            <a:ext cx="1195247" cy="739759"/>
-          </a:xfrm>
-          <a:prstGeom prst="straightConnector1">
-            <a:avLst/>
-          </a:prstGeom>
-          <a:ln>
-            <a:headEnd type="none" w="med" len="med"/>
-            <a:tailEnd type="arrow" w="med" len="med"/>
-          </a:ln>
-        </p:spPr>
-        <p:style>
-          <a:lnRef idx="3">
-            <a:schemeClr val="dk1"/>
-          </a:lnRef>
-          <a:fillRef idx="0">
-            <a:schemeClr val="dk1"/>
-          </a:fillRef>
-          <a:effectRef idx="2">
-            <a:schemeClr val="dk1"/>
-          </a:effectRef>
-          <a:fontRef idx="minor">
-            <a:schemeClr val="tx1"/>
-          </a:fontRef>
-        </p:style>
-      </p:cxnSp>
-      <p:sp>
-        <p:nvSpPr>
-          <p:cNvPr id="16" name="Rechteck: abgerundete Ecken 15">
-            <a:extLst>
-              <a:ext uri="{FF2B5EF4-FFF2-40B4-BE49-F238E27FC236}">
-                <a16:creationId xmlns:a16="http://schemas.microsoft.com/office/drawing/2014/main" id="{F1DBB668-4150-1DE3-13CE-53CC70D585A6}"/>
-              </a:ext>
-            </a:extLst>
-          </p:cNvPr>
-          <p:cNvSpPr/>
-          <p:nvPr/>
-        </p:nvSpPr>
-        <p:spPr>
-          <a:xfrm>
-            <a:off x="6261622" y="3648809"/>
-            <a:ext cx="2733427" cy="841248"/>
-          </a:xfrm>
-          <a:prstGeom prst="roundRect">
-            <a:avLst/>
-          </a:prstGeom>
-          <a:solidFill>
-            <a:srgbClr val="FFFFCC"/>
-          </a:solidFill>
-        </p:spPr>
-        <p:style>
-          <a:lnRef idx="2">
-            <a:schemeClr val="accent1">
-              <a:shade val="15000"/>
-            </a:schemeClr>
-          </a:lnRef>
-          <a:fillRef idx="1">
-            <a:schemeClr val="accent1"/>
-          </a:fillRef>
-          <a:effectRef idx="0">
-            <a:schemeClr val="accent1"/>
-          </a:effectRef>
-          <a:fontRef idx="minor">
-            <a:schemeClr val="lt1"/>
-          </a:fontRef>
-        </p:style>
-        <p:txBody>
-          <a:bodyPr rtlCol="0" anchor="ctr"/>
-          <a:lstStyle/>
-          <a:p>
-            <a:pPr algn="ctr"/>
-            <a:r>
-              <a:rPr lang="en-GB" noProof="0" dirty="0">
-                <a:solidFill>
-                  <a:schemeClr val="tx1"/>
-                </a:solidFill>
-              </a:rPr>
-              <a:t>Code</a:t>
-            </a:r>
-          </a:p>
-        </p:txBody>
-      </p:sp>
-      <p:sp>
-        <p:nvSpPr>
-          <p:cNvPr id="13" name="Textfeld 12">
-            <a:extLst>
-              <a:ext uri="{FF2B5EF4-FFF2-40B4-BE49-F238E27FC236}">
-                <a16:creationId xmlns:a16="http://schemas.microsoft.com/office/drawing/2014/main" id="{6C12A045-772B-0FBE-AC43-41C8BBD9E99B}"/>
-              </a:ext>
-            </a:extLst>
-          </p:cNvPr>
-          <p:cNvSpPr txBox="1"/>
-          <p:nvPr/>
-        </p:nvSpPr>
-        <p:spPr>
-          <a:xfrm>
-            <a:off x="7798707" y="3012984"/>
-            <a:ext cx="774656" cy="369332"/>
-          </a:xfrm>
-          <a:prstGeom prst="rect">
-            <a:avLst/>
-          </a:prstGeom>
-          <a:solidFill>
-            <a:schemeClr val="bg1"/>
-          </a:solidFill>
-          <a:ln>
-            <a:solidFill>
-              <a:schemeClr val="tx1"/>
-            </a:solidFill>
-          </a:ln>
-        </p:spPr>
-        <p:txBody>
-          <a:bodyPr wrap="square" rtlCol="0">
-            <a:spAutoFit/>
-          </a:bodyPr>
-          <a:lstStyle/>
-          <a:p>
-            <a:r>
-              <a:rPr lang="en-US" dirty="0"/>
-              <a:t>False</a:t>
-            </a:r>
-            <a:endParaRPr lang="de-DE" dirty="0"/>
-          </a:p>
-        </p:txBody>
-      </p:sp>
-      <p:sp>
-        <p:nvSpPr>
-          <p:cNvPr id="37" name="Rechteck: abgerundete Ecken 36">
-            <a:extLst>
-              <a:ext uri="{FF2B5EF4-FFF2-40B4-BE49-F238E27FC236}">
-                <a16:creationId xmlns:a16="http://schemas.microsoft.com/office/drawing/2014/main" id="{E63E1191-2AD7-F354-BD40-5C33059EB9DE}"/>
-              </a:ext>
-            </a:extLst>
-          </p:cNvPr>
-          <p:cNvSpPr/>
-          <p:nvPr/>
-        </p:nvSpPr>
-        <p:spPr>
-          <a:xfrm>
-            <a:off x="130425" y="1861255"/>
-            <a:ext cx="2733427" cy="841248"/>
-          </a:xfrm>
-          <a:prstGeom prst="roundRect">
-            <a:avLst/>
-          </a:prstGeom>
-          <a:solidFill>
-            <a:srgbClr val="FFFFCC"/>
-          </a:solidFill>
-        </p:spPr>
-        <p:style>
-          <a:lnRef idx="2">
-            <a:schemeClr val="accent1">
-              <a:shade val="15000"/>
-            </a:schemeClr>
-          </a:lnRef>
-          <a:fillRef idx="1">
-            <a:schemeClr val="accent1"/>
-          </a:fillRef>
-          <a:effectRef idx="0">
-            <a:schemeClr val="accent1"/>
-          </a:effectRef>
-          <a:fontRef idx="minor">
-            <a:schemeClr val="lt1"/>
-          </a:fontRef>
-        </p:style>
-        <p:txBody>
-          <a:bodyPr rtlCol="0" anchor="ctr"/>
-          <a:lstStyle/>
-          <a:p>
-            <a:pPr algn="ctr"/>
-            <a:r>
-              <a:rPr lang="en-GB" dirty="0">
-                <a:solidFill>
-                  <a:schemeClr val="tx1"/>
-                </a:solidFill>
-              </a:rPr>
-              <a:t>if - Condition</a:t>
-            </a:r>
-            <a:endParaRPr lang="en-GB" noProof="0" dirty="0">
+            <a:ln>
               <a:solidFill>
                 <a:schemeClr val="tx1"/>
               </a:solidFill>
-            </a:endParaRPr>
-          </a:p>
-        </p:txBody>
-      </p:sp>
-      <p:sp>
-        <p:nvSpPr>
-          <p:cNvPr id="38" name="Rechteck: abgerundete Ecken 37">
-            <a:extLst>
-              <a:ext uri="{FF2B5EF4-FFF2-40B4-BE49-F238E27FC236}">
-                <a16:creationId xmlns:a16="http://schemas.microsoft.com/office/drawing/2014/main" id="{9F45DB8C-28F2-F23D-79DC-3A8BA3E30F61}"/>
-              </a:ext>
-            </a:extLst>
-          </p:cNvPr>
-          <p:cNvSpPr/>
-          <p:nvPr/>
-        </p:nvSpPr>
-        <p:spPr>
-          <a:xfrm>
-            <a:off x="1989370" y="3687546"/>
-            <a:ext cx="2733427" cy="841248"/>
-          </a:xfrm>
-          <a:prstGeom prst="roundRect">
-            <a:avLst/>
-          </a:prstGeom>
-          <a:solidFill>
-            <a:srgbClr val="FFFFCC"/>
-          </a:solidFill>
-        </p:spPr>
-        <p:style>
-          <a:lnRef idx="2">
-            <a:schemeClr val="accent1">
-              <a:shade val="15000"/>
-            </a:schemeClr>
-          </a:lnRef>
-          <a:fillRef idx="1">
-            <a:schemeClr val="accent1"/>
-          </a:fillRef>
-          <a:effectRef idx="0">
-            <a:schemeClr val="accent1"/>
-          </a:effectRef>
-          <a:fontRef idx="minor">
-            <a:schemeClr val="lt1"/>
-          </a:fontRef>
-        </p:style>
-        <p:txBody>
-          <a:bodyPr rtlCol="0" anchor="ctr"/>
-          <a:lstStyle/>
-          <a:p>
-            <a:pPr algn="ctr"/>
-            <a:r>
-              <a:rPr lang="en-GB" noProof="0" dirty="0">
-                <a:solidFill>
-                  <a:schemeClr val="tx1"/>
-                </a:solidFill>
-              </a:rPr>
-              <a:t>Code</a:t>
-            </a:r>
-          </a:p>
-        </p:txBody>
-      </p:sp>
-      <p:sp>
-        <p:nvSpPr>
-          <p:cNvPr id="39" name="Rechteck: abgerundete Ecken 38">
-            <a:extLst>
-              <a:ext uri="{FF2B5EF4-FFF2-40B4-BE49-F238E27FC236}">
-                <a16:creationId xmlns:a16="http://schemas.microsoft.com/office/drawing/2014/main" id="{CCCAAA7C-4625-CAE3-40BE-A672B37E9FDF}"/>
-              </a:ext>
-            </a:extLst>
-          </p:cNvPr>
-          <p:cNvSpPr/>
-          <p:nvPr/>
-        </p:nvSpPr>
-        <p:spPr>
-          <a:xfrm>
-            <a:off x="130424" y="634351"/>
-            <a:ext cx="2733427" cy="841248"/>
-          </a:xfrm>
-          <a:prstGeom prst="roundRect">
-            <a:avLst/>
-          </a:prstGeom>
-          <a:solidFill>
-            <a:srgbClr val="FFFFCC"/>
-          </a:solidFill>
-        </p:spPr>
-        <p:style>
-          <a:lnRef idx="2">
-            <a:schemeClr val="accent1">
-              <a:shade val="15000"/>
-            </a:schemeClr>
-          </a:lnRef>
-          <a:fillRef idx="1">
-            <a:schemeClr val="accent1"/>
-          </a:fillRef>
-          <a:effectRef idx="0">
-            <a:schemeClr val="accent1"/>
-          </a:effectRef>
-          <a:fontRef idx="minor">
-            <a:schemeClr val="lt1"/>
-          </a:fontRef>
-        </p:style>
-        <p:txBody>
-          <a:bodyPr rtlCol="0" anchor="ctr"/>
-          <a:lstStyle/>
-          <a:p>
-            <a:pPr algn="ctr"/>
-            <a:r>
-              <a:rPr lang="en-GB" noProof="0" dirty="0">
-                <a:solidFill>
-                  <a:schemeClr val="tx1"/>
-                </a:solidFill>
-              </a:rPr>
-              <a:t>Code</a:t>
-            </a:r>
-          </a:p>
-        </p:txBody>
-      </p:sp>
-      <p:sp>
-        <p:nvSpPr>
-          <p:cNvPr id="40" name="Rechteck: abgerundete Ecken 39">
-            <a:extLst>
-              <a:ext uri="{FF2B5EF4-FFF2-40B4-BE49-F238E27FC236}">
-                <a16:creationId xmlns:a16="http://schemas.microsoft.com/office/drawing/2014/main" id="{E868DF51-CBF5-34F3-2FB6-F47074E84AB7}"/>
-              </a:ext>
-            </a:extLst>
-          </p:cNvPr>
-          <p:cNvSpPr/>
-          <p:nvPr/>
-        </p:nvSpPr>
-        <p:spPr>
-          <a:xfrm>
-            <a:off x="130424" y="5268553"/>
-            <a:ext cx="2733427" cy="841248"/>
-          </a:xfrm>
-          <a:prstGeom prst="roundRect">
-            <a:avLst/>
-          </a:prstGeom>
-          <a:solidFill>
-            <a:srgbClr val="FFFFCC"/>
-          </a:solidFill>
-        </p:spPr>
-        <p:style>
-          <a:lnRef idx="2">
-            <a:schemeClr val="accent1">
-              <a:shade val="15000"/>
-            </a:schemeClr>
-          </a:lnRef>
-          <a:fillRef idx="1">
-            <a:schemeClr val="accent1"/>
-          </a:fillRef>
-          <a:effectRef idx="0">
-            <a:schemeClr val="accent1"/>
-          </a:effectRef>
-          <a:fontRef idx="minor">
-            <a:schemeClr val="lt1"/>
-          </a:fontRef>
-        </p:style>
-        <p:txBody>
-          <a:bodyPr rtlCol="0" anchor="ctr"/>
-          <a:lstStyle/>
-          <a:p>
-            <a:pPr algn="ctr"/>
-            <a:r>
-              <a:rPr lang="en-GB" noProof="0" dirty="0">
-                <a:solidFill>
-                  <a:schemeClr val="tx1"/>
-                </a:solidFill>
-              </a:rPr>
-              <a:t>Code</a:t>
-            </a:r>
-          </a:p>
-        </p:txBody>
-      </p:sp>
-      <p:cxnSp>
-        <p:nvCxnSpPr>
-          <p:cNvPr id="41" name="Gerade Verbindung mit Pfeil 40">
-            <a:extLst>
-              <a:ext uri="{FF2B5EF4-FFF2-40B4-BE49-F238E27FC236}">
-                <a16:creationId xmlns:a16="http://schemas.microsoft.com/office/drawing/2014/main" id="{FB304E74-A35A-56C0-5511-04E8A32B2F48}"/>
-              </a:ext>
-            </a:extLst>
-          </p:cNvPr>
-          <p:cNvCxnSpPr>
-            <a:cxnSpLocks/>
-            <a:stCxn id="37" idx="2"/>
-            <a:endCxn id="38" idx="0"/>
-          </p:cNvCxnSpPr>
-          <p:nvPr/>
-        </p:nvCxnSpPr>
-        <p:spPr>
-          <a:xfrm>
-            <a:off x="1497139" y="2702503"/>
-            <a:ext cx="1858945" cy="985043"/>
-          </a:xfrm>
-          <a:prstGeom prst="straightConnector1">
-            <a:avLst/>
-          </a:prstGeom>
-          <a:ln>
-            <a:headEnd type="none" w="med" len="med"/>
-            <a:tailEnd type="arrow" w="med" len="med"/>
-          </a:ln>
-        </p:spPr>
-        <p:style>
-          <a:lnRef idx="3">
-            <a:schemeClr val="dk1"/>
-          </a:lnRef>
-          <a:fillRef idx="0">
-            <a:schemeClr val="dk1"/>
-          </a:fillRef>
-          <a:effectRef idx="2">
-            <a:schemeClr val="dk1"/>
-          </a:effectRef>
-          <a:fontRef idx="minor">
-            <a:schemeClr val="tx1"/>
-          </a:fontRef>
-        </p:style>
-      </p:cxnSp>
-      <p:cxnSp>
-        <p:nvCxnSpPr>
-          <p:cNvPr id="42" name="Gerade Verbindung mit Pfeil 41">
-            <a:extLst>
-              <a:ext uri="{FF2B5EF4-FFF2-40B4-BE49-F238E27FC236}">
-                <a16:creationId xmlns:a16="http://schemas.microsoft.com/office/drawing/2014/main" id="{7789AECA-1B6E-32DA-D5C3-2BDB774E9336}"/>
-              </a:ext>
-            </a:extLst>
-          </p:cNvPr>
-          <p:cNvCxnSpPr>
-            <a:cxnSpLocks/>
-            <a:stCxn id="39" idx="2"/>
-            <a:endCxn id="37" idx="0"/>
-          </p:cNvCxnSpPr>
-          <p:nvPr/>
-        </p:nvCxnSpPr>
-        <p:spPr>
-          <a:xfrm>
-            <a:off x="1497138" y="1475599"/>
-            <a:ext cx="1" cy="385656"/>
-          </a:xfrm>
-          <a:prstGeom prst="straightConnector1">
-            <a:avLst/>
-          </a:prstGeom>
-          <a:ln>
-            <a:headEnd type="none" w="med" len="med"/>
-            <a:tailEnd type="arrow" w="med" len="med"/>
-          </a:ln>
-        </p:spPr>
-        <p:style>
-          <a:lnRef idx="3">
-            <a:schemeClr val="dk1"/>
-          </a:lnRef>
-          <a:fillRef idx="0">
-            <a:schemeClr val="dk1"/>
-          </a:fillRef>
-          <a:effectRef idx="2">
-            <a:schemeClr val="dk1"/>
-          </a:effectRef>
-          <a:fontRef idx="minor">
-            <a:schemeClr val="tx1"/>
-          </a:fontRef>
-        </p:style>
-      </p:cxnSp>
-      <p:cxnSp>
-        <p:nvCxnSpPr>
-          <p:cNvPr id="43" name="Gerade Verbindung mit Pfeil 42">
-            <a:extLst>
-              <a:ext uri="{FF2B5EF4-FFF2-40B4-BE49-F238E27FC236}">
-                <a16:creationId xmlns:a16="http://schemas.microsoft.com/office/drawing/2014/main" id="{4A3E2242-7152-1103-701F-279C6B56229B}"/>
-              </a:ext>
-            </a:extLst>
-          </p:cNvPr>
-          <p:cNvCxnSpPr>
-            <a:cxnSpLocks/>
-            <a:stCxn id="37" idx="2"/>
-            <a:endCxn id="40" idx="0"/>
-          </p:cNvCxnSpPr>
-          <p:nvPr/>
-        </p:nvCxnSpPr>
-        <p:spPr>
-          <a:xfrm flipH="1">
-            <a:off x="1497138" y="2702503"/>
-            <a:ext cx="1" cy="2566050"/>
-          </a:xfrm>
-          <a:prstGeom prst="straightConnector1">
-            <a:avLst/>
-          </a:prstGeom>
-          <a:ln>
-            <a:headEnd type="none" w="med" len="med"/>
-            <a:tailEnd type="arrow" w="med" len="med"/>
-          </a:ln>
-        </p:spPr>
-        <p:style>
-          <a:lnRef idx="3">
-            <a:schemeClr val="dk1"/>
-          </a:lnRef>
-          <a:fillRef idx="0">
-            <a:schemeClr val="dk1"/>
-          </a:fillRef>
-          <a:effectRef idx="2">
-            <a:schemeClr val="dk1"/>
-          </a:effectRef>
-          <a:fontRef idx="minor">
-            <a:schemeClr val="tx1"/>
-          </a:fontRef>
-        </p:style>
-      </p:cxnSp>
-      <p:cxnSp>
-        <p:nvCxnSpPr>
-          <p:cNvPr id="44" name="Gerade Verbindung mit Pfeil 43">
-            <a:extLst>
-              <a:ext uri="{FF2B5EF4-FFF2-40B4-BE49-F238E27FC236}">
-                <a16:creationId xmlns:a16="http://schemas.microsoft.com/office/drawing/2014/main" id="{B4F791B1-C516-74C1-410C-AC2A6EDD00E7}"/>
-              </a:ext>
-            </a:extLst>
-          </p:cNvPr>
-          <p:cNvCxnSpPr>
-            <a:cxnSpLocks/>
-          </p:cNvCxnSpPr>
-          <p:nvPr/>
-        </p:nvCxnSpPr>
-        <p:spPr>
-          <a:xfrm flipH="1">
-            <a:off x="1497138" y="4528794"/>
-            <a:ext cx="1858946" cy="739759"/>
-          </a:xfrm>
-          <a:prstGeom prst="straightConnector1">
-            <a:avLst/>
-          </a:prstGeom>
-          <a:ln>
-            <a:headEnd type="none" w="med" len="med"/>
-            <a:tailEnd type="arrow" w="med" len="med"/>
-          </a:ln>
-        </p:spPr>
-        <p:style>
-          <a:lnRef idx="3">
-            <a:schemeClr val="dk1"/>
-          </a:lnRef>
-          <a:fillRef idx="0">
-            <a:schemeClr val="dk1"/>
-          </a:fillRef>
-          <a:effectRef idx="2">
-            <a:schemeClr val="dk1"/>
-          </a:effectRef>
-          <a:fontRef idx="minor">
-            <a:schemeClr val="tx1"/>
-          </a:fontRef>
-        </p:style>
-      </p:cxnSp>
-      <p:sp>
-        <p:nvSpPr>
-          <p:cNvPr id="45" name="Textfeld 44">
-            <a:extLst>
-              <a:ext uri="{FF2B5EF4-FFF2-40B4-BE49-F238E27FC236}">
-                <a16:creationId xmlns:a16="http://schemas.microsoft.com/office/drawing/2014/main" id="{4F2C637F-8D54-8E10-2820-74622DED5FB7}"/>
-              </a:ext>
-            </a:extLst>
-          </p:cNvPr>
-          <p:cNvSpPr txBox="1"/>
-          <p:nvPr/>
-        </p:nvSpPr>
-        <p:spPr>
-          <a:xfrm>
-            <a:off x="2213217" y="3037476"/>
-            <a:ext cx="650634" cy="369332"/>
-          </a:xfrm>
-          <a:prstGeom prst="rect">
-            <a:avLst/>
-          </a:prstGeom>
-          <a:solidFill>
-            <a:schemeClr val="bg1"/>
-          </a:solidFill>
-          <a:ln>
+            </a:ln>
+          </p:spPr>
+          <p:txBody>
+            <a:bodyPr wrap="square" rtlCol="0">
+              <a:spAutoFit/>
+            </a:bodyPr>
+            <a:lstStyle/>
+            <a:p>
+              <a:r>
+                <a:rPr lang="en-US" dirty="0"/>
+                <a:t>True</a:t>
+              </a:r>
+              <a:endParaRPr lang="de-DE" dirty="0"/>
+            </a:p>
+          </p:txBody>
+        </p:sp>
+        <p:sp>
+          <p:nvSpPr>
+            <p:cNvPr id="46" name="Textfeld 45">
+              <a:extLst>
+                <a:ext uri="{FF2B5EF4-FFF2-40B4-BE49-F238E27FC236}">
+                  <a16:creationId xmlns:a16="http://schemas.microsoft.com/office/drawing/2014/main" id="{6CD50F20-C952-4A74-1884-F8CADA83CF0E}"/>
+                </a:ext>
+              </a:extLst>
+            </p:cNvPr>
+            <p:cNvSpPr txBox="1"/>
+            <p:nvPr/>
+          </p:nvSpPr>
+          <p:spPr>
+            <a:xfrm>
+              <a:off x="1109811" y="3184293"/>
+              <a:ext cx="774656" cy="369332"/>
+            </a:xfrm>
+            <a:prstGeom prst="rect">
+              <a:avLst/>
+            </a:prstGeom>
             <a:solidFill>
-              <a:schemeClr val="tx1"/>
+              <a:schemeClr val="bg1"/>
             </a:solidFill>
-          </a:ln>
-        </p:spPr>
-        <p:txBody>
-          <a:bodyPr wrap="square" rtlCol="0">
-            <a:spAutoFit/>
-          </a:bodyPr>
-          <a:lstStyle/>
-          <a:p>
-            <a:r>
-              <a:rPr lang="en-US" dirty="0"/>
-              <a:t>True</a:t>
-            </a:r>
-            <a:endParaRPr lang="de-DE" dirty="0"/>
-          </a:p>
-        </p:txBody>
-      </p:sp>
-      <p:sp>
-        <p:nvSpPr>
-          <p:cNvPr id="46" name="Textfeld 45">
-            <a:extLst>
-              <a:ext uri="{FF2B5EF4-FFF2-40B4-BE49-F238E27FC236}">
-                <a16:creationId xmlns:a16="http://schemas.microsoft.com/office/drawing/2014/main" id="{6CD50F20-C952-4A74-1884-F8CADA83CF0E}"/>
-              </a:ext>
-            </a:extLst>
-          </p:cNvPr>
-          <p:cNvSpPr txBox="1"/>
-          <p:nvPr/>
-        </p:nvSpPr>
-        <p:spPr>
-          <a:xfrm>
-            <a:off x="1109811" y="3184293"/>
-            <a:ext cx="774656" cy="369332"/>
-          </a:xfrm>
-          <a:prstGeom prst="rect">
-            <a:avLst/>
-          </a:prstGeom>
-          <a:solidFill>
-            <a:schemeClr val="bg1"/>
-          </a:solidFill>
-          <a:ln>
-            <a:solidFill>
-              <a:schemeClr val="tx1"/>
-            </a:solidFill>
-          </a:ln>
-        </p:spPr>
-        <p:txBody>
-          <a:bodyPr wrap="square" rtlCol="0">
-            <a:spAutoFit/>
-          </a:bodyPr>
-          <a:lstStyle/>
-          <a:p>
-            <a:r>
-              <a:rPr lang="en-US" dirty="0"/>
-              <a:t>False</a:t>
-            </a:r>
-            <a:endParaRPr lang="de-DE" dirty="0"/>
-          </a:p>
-        </p:txBody>
-      </p:sp>
+            <a:ln>
+              <a:solidFill>
+                <a:schemeClr val="tx1"/>
+              </a:solidFill>
+            </a:ln>
+          </p:spPr>
+          <p:txBody>
+            <a:bodyPr wrap="square" rtlCol="0">
+              <a:spAutoFit/>
+            </a:bodyPr>
+            <a:lstStyle/>
+            <a:p>
+              <a:r>
+                <a:rPr lang="en-US" dirty="0"/>
+                <a:t>False</a:t>
+              </a:r>
+              <a:endParaRPr lang="de-DE" dirty="0"/>
+            </a:p>
+          </p:txBody>
+        </p:sp>
+      </p:grpSp>
       <p:cxnSp>
         <p:nvCxnSpPr>
           <p:cNvPr id="47" name="Gerade Verbindung mit Pfeil 46">
@@ -8195,6 +8575,108 @@
   <p:clrMapOvr>
     <a:masterClrMapping/>
   </p:clrMapOvr>
+  <p:timing>
+    <p:tnLst>
+      <p:par>
+        <p:cTn id="1" dur="indefinite" restart="never" nodeType="tmRoot">
+          <p:childTnLst>
+            <p:seq concurrent="1" nextAc="seek">
+              <p:cTn id="2" dur="indefinite" nodeType="mainSeq">
+                <p:childTnLst>
+                  <p:par>
+                    <p:cTn id="3" fill="hold">
+                      <p:stCondLst>
+                        <p:cond delay="indefinite"/>
+                      </p:stCondLst>
+                      <p:childTnLst>
+                        <p:par>
+                          <p:cTn id="4" fill="hold">
+                            <p:stCondLst>
+                              <p:cond delay="0"/>
+                            </p:stCondLst>
+                            <p:childTnLst>
+                              <p:par>
+                                <p:cTn id="5" presetID="1" presetClass="entr" presetSubtype="0" fill="hold" nodeType="clickEffect">
+                                  <p:stCondLst>
+                                    <p:cond delay="0"/>
+                                  </p:stCondLst>
+                                  <p:childTnLst>
+                                    <p:set>
+                                      <p:cBhvr>
+                                        <p:cTn id="6" dur="1" fill="hold">
+                                          <p:stCondLst>
+                                            <p:cond delay="0"/>
+                                          </p:stCondLst>
+                                        </p:cTn>
+                                        <p:tgtEl>
+                                          <p:spTgt spid="47"/>
+                                        </p:tgtEl>
+                                        <p:attrNameLst>
+                                          <p:attrName>style.visibility</p:attrName>
+                                        </p:attrNameLst>
+                                      </p:cBhvr>
+                                      <p:to>
+                                        <p:strVal val="visible"/>
+                                      </p:to>
+                                    </p:set>
+                                  </p:childTnLst>
+                                </p:cTn>
+                              </p:par>
+                              <p:par>
+                                <p:cTn id="7" presetID="1" presetClass="entr" presetSubtype="0" fill="hold" nodeType="withEffect">
+                                  <p:stCondLst>
+                                    <p:cond delay="0"/>
+                                  </p:stCondLst>
+                                  <p:childTnLst>
+                                    <p:set>
+                                      <p:cBhvr>
+                                        <p:cTn id="8" dur="1" fill="hold">
+                                          <p:stCondLst>
+                                            <p:cond delay="0"/>
+                                          </p:stCondLst>
+                                        </p:cTn>
+                                        <p:tgtEl>
+                                          <p:spTgt spid="10"/>
+                                        </p:tgtEl>
+                                        <p:attrNameLst>
+                                          <p:attrName>style.visibility</p:attrName>
+                                        </p:attrNameLst>
+                                      </p:cBhvr>
+                                      <p:to>
+                                        <p:strVal val="visible"/>
+                                      </p:to>
+                                    </p:set>
+                                  </p:childTnLst>
+                                </p:cTn>
+                              </p:par>
+                            </p:childTnLst>
+                          </p:cTn>
+                        </p:par>
+                      </p:childTnLst>
+                    </p:cTn>
+                  </p:par>
+                </p:childTnLst>
+              </p:cTn>
+              <p:prevCondLst>
+                <p:cond evt="onPrev" delay="0">
+                  <p:tgtEl>
+                    <p:sldTgt/>
+                  </p:tgtEl>
+                </p:cond>
+              </p:prevCondLst>
+              <p:nextCondLst>
+                <p:cond evt="onNext" delay="0">
+                  <p:tgtEl>
+                    <p:sldTgt/>
+                  </p:tgtEl>
+                </p:cond>
+              </p:nextCondLst>
+            </p:seq>
+          </p:childTnLst>
+        </p:cTn>
+      </p:par>
+    </p:tnLst>
+  </p:timing>
 </p:sld>
 </file>
 
@@ -9011,6 +9493,183 @@
   <p:clrMapOvr>
     <a:masterClrMapping/>
   </p:clrMapOvr>
+  <p:timing>
+    <p:tnLst>
+      <p:par>
+        <p:cTn id="1" dur="indefinite" restart="never" nodeType="tmRoot">
+          <p:childTnLst>
+            <p:seq concurrent="1" nextAc="seek">
+              <p:cTn id="2" dur="indefinite" nodeType="mainSeq">
+                <p:childTnLst>
+                  <p:par>
+                    <p:cTn id="3" fill="hold">
+                      <p:stCondLst>
+                        <p:cond delay="indefinite"/>
+                      </p:stCondLst>
+                      <p:childTnLst>
+                        <p:par>
+                          <p:cTn id="4" fill="hold">
+                            <p:stCondLst>
+                              <p:cond delay="0"/>
+                            </p:stCondLst>
+                            <p:childTnLst>
+                              <p:par>
+                                <p:cTn id="5" presetID="1" presetClass="entr" presetSubtype="0" fill="hold" nodeType="clickEffect">
+                                  <p:stCondLst>
+                                    <p:cond delay="0"/>
+                                  </p:stCondLst>
+                                  <p:childTnLst>
+                                    <p:set>
+                                      <p:cBhvr>
+                                        <p:cTn id="6" dur="1" fill="hold">
+                                          <p:stCondLst>
+                                            <p:cond delay="0"/>
+                                          </p:stCondLst>
+                                        </p:cTn>
+                                        <p:tgtEl>
+                                          <p:spTgt spid="17"/>
+                                        </p:tgtEl>
+                                        <p:attrNameLst>
+                                          <p:attrName>style.visibility</p:attrName>
+                                        </p:attrNameLst>
+                                      </p:cBhvr>
+                                      <p:to>
+                                        <p:strVal val="visible"/>
+                                      </p:to>
+                                    </p:set>
+                                  </p:childTnLst>
+                                </p:cTn>
+                              </p:par>
+                            </p:childTnLst>
+                          </p:cTn>
+                        </p:par>
+                      </p:childTnLst>
+                    </p:cTn>
+                  </p:par>
+                  <p:par>
+                    <p:cTn id="7" fill="hold">
+                      <p:stCondLst>
+                        <p:cond delay="indefinite"/>
+                      </p:stCondLst>
+                      <p:childTnLst>
+                        <p:par>
+                          <p:cTn id="8" fill="hold">
+                            <p:stCondLst>
+                              <p:cond delay="0"/>
+                            </p:stCondLst>
+                            <p:childTnLst>
+                              <p:par>
+                                <p:cTn id="9" presetID="1" presetClass="entr" presetSubtype="0" fill="hold" nodeType="clickEffect">
+                                  <p:stCondLst>
+                                    <p:cond delay="0"/>
+                                  </p:stCondLst>
+                                  <p:childTnLst>
+                                    <p:set>
+                                      <p:cBhvr>
+                                        <p:cTn id="10" dur="1" fill="hold">
+                                          <p:stCondLst>
+                                            <p:cond delay="0"/>
+                                          </p:stCondLst>
+                                        </p:cTn>
+                                        <p:tgtEl>
+                                          <p:spTgt spid="19"/>
+                                        </p:tgtEl>
+                                        <p:attrNameLst>
+                                          <p:attrName>style.visibility</p:attrName>
+                                        </p:attrNameLst>
+                                      </p:cBhvr>
+                                      <p:to>
+                                        <p:strVal val="visible"/>
+                                      </p:to>
+                                    </p:set>
+                                  </p:childTnLst>
+                                </p:cTn>
+                              </p:par>
+                              <p:par>
+                                <p:cTn id="11" presetID="1" presetClass="entr" presetSubtype="0" fill="hold" grpId="0" nodeType="withEffect">
+                                  <p:stCondLst>
+                                    <p:cond delay="0"/>
+                                  </p:stCondLst>
+                                  <p:childTnLst>
+                                    <p:set>
+                                      <p:cBhvr>
+                                        <p:cTn id="12" dur="1" fill="hold">
+                                          <p:stCondLst>
+                                            <p:cond delay="0"/>
+                                          </p:stCondLst>
+                                        </p:cTn>
+                                        <p:tgtEl>
+                                          <p:spTgt spid="18"/>
+                                        </p:tgtEl>
+                                        <p:attrNameLst>
+                                          <p:attrName>style.visibility</p:attrName>
+                                        </p:attrNameLst>
+                                      </p:cBhvr>
+                                      <p:to>
+                                        <p:strVal val="visible"/>
+                                      </p:to>
+                                    </p:set>
+                                  </p:childTnLst>
+                                </p:cTn>
+                              </p:par>
+                              <p:par>
+                                <p:cTn id="13" presetID="1" presetClass="entr" presetSubtype="0" fill="hold" nodeType="withEffect">
+                                  <p:stCondLst>
+                                    <p:cond delay="0"/>
+                                  </p:stCondLst>
+                                  <p:childTnLst>
+                                    <p:set>
+                                      <p:cBhvr>
+                                        <p:cTn id="14" dur="1" fill="hold">
+                                          <p:stCondLst>
+                                            <p:cond delay="0"/>
+                                          </p:stCondLst>
+                                        </p:cTn>
+                                        <p:tgtEl>
+                                          <p:spTgt spid="10"/>
+                                        </p:tgtEl>
+                                        <p:attrNameLst>
+                                          <p:attrName>style.visibility</p:attrName>
+                                        </p:attrNameLst>
+                                      </p:cBhvr>
+                                      <p:to>
+                                        <p:strVal val="visible"/>
+                                      </p:to>
+                                    </p:set>
+                                  </p:childTnLst>
+                                </p:cTn>
+                              </p:par>
+                            </p:childTnLst>
+                          </p:cTn>
+                        </p:par>
+                      </p:childTnLst>
+                    </p:cTn>
+                  </p:par>
+                </p:childTnLst>
+              </p:cTn>
+              <p:prevCondLst>
+                <p:cond evt="onPrev" delay="0">
+                  <p:tgtEl>
+                    <p:sldTgt/>
+                  </p:tgtEl>
+                </p:cond>
+              </p:prevCondLst>
+              <p:nextCondLst>
+                <p:cond evt="onNext" delay="0">
+                  <p:tgtEl>
+                    <p:sldTgt/>
+                  </p:tgtEl>
+                </p:cond>
+              </p:nextCondLst>
+            </p:seq>
+          </p:childTnLst>
+        </p:cTn>
+      </p:par>
+    </p:tnLst>
+    <p:bldLst>
+      <p:bldP spid="18" grpId="0"/>
+    </p:bldLst>
+  </p:timing>
 </p:sld>
 </file>
 
@@ -10099,6 +10758,183 @@
   <p:clrMapOvr>
     <a:masterClrMapping/>
   </p:clrMapOvr>
+  <p:timing>
+    <p:tnLst>
+      <p:par>
+        <p:cTn id="1" dur="indefinite" restart="never" nodeType="tmRoot">
+          <p:childTnLst>
+            <p:seq concurrent="1" nextAc="seek">
+              <p:cTn id="2" dur="indefinite" nodeType="mainSeq">
+                <p:childTnLst>
+                  <p:par>
+                    <p:cTn id="3" fill="hold">
+                      <p:stCondLst>
+                        <p:cond delay="indefinite"/>
+                      </p:stCondLst>
+                      <p:childTnLst>
+                        <p:par>
+                          <p:cTn id="4" fill="hold">
+                            <p:stCondLst>
+                              <p:cond delay="0"/>
+                            </p:stCondLst>
+                            <p:childTnLst>
+                              <p:par>
+                                <p:cTn id="5" presetID="1" presetClass="entr" presetSubtype="0" fill="hold" nodeType="clickEffect">
+                                  <p:stCondLst>
+                                    <p:cond delay="0"/>
+                                  </p:stCondLst>
+                                  <p:childTnLst>
+                                    <p:set>
+                                      <p:cBhvr>
+                                        <p:cTn id="6" dur="1" fill="hold">
+                                          <p:stCondLst>
+                                            <p:cond delay="0"/>
+                                          </p:stCondLst>
+                                        </p:cTn>
+                                        <p:tgtEl>
+                                          <p:spTgt spid="51"/>
+                                        </p:tgtEl>
+                                        <p:attrNameLst>
+                                          <p:attrName>style.visibility</p:attrName>
+                                        </p:attrNameLst>
+                                      </p:cBhvr>
+                                      <p:to>
+                                        <p:strVal val="visible"/>
+                                      </p:to>
+                                    </p:set>
+                                  </p:childTnLst>
+                                </p:cTn>
+                              </p:par>
+                            </p:childTnLst>
+                          </p:cTn>
+                        </p:par>
+                      </p:childTnLst>
+                    </p:cTn>
+                  </p:par>
+                  <p:par>
+                    <p:cTn id="7" fill="hold">
+                      <p:stCondLst>
+                        <p:cond delay="indefinite"/>
+                      </p:stCondLst>
+                      <p:childTnLst>
+                        <p:par>
+                          <p:cTn id="8" fill="hold">
+                            <p:stCondLst>
+                              <p:cond delay="0"/>
+                            </p:stCondLst>
+                            <p:childTnLst>
+                              <p:par>
+                                <p:cTn id="9" presetID="1" presetClass="entr" presetSubtype="0" fill="hold" nodeType="clickEffect">
+                                  <p:stCondLst>
+                                    <p:cond delay="0"/>
+                                  </p:stCondLst>
+                                  <p:childTnLst>
+                                    <p:set>
+                                      <p:cBhvr>
+                                        <p:cTn id="10" dur="1" fill="hold">
+                                          <p:stCondLst>
+                                            <p:cond delay="0"/>
+                                          </p:stCondLst>
+                                        </p:cTn>
+                                        <p:tgtEl>
+                                          <p:spTgt spid="48"/>
+                                        </p:tgtEl>
+                                        <p:attrNameLst>
+                                          <p:attrName>style.visibility</p:attrName>
+                                        </p:attrNameLst>
+                                      </p:cBhvr>
+                                      <p:to>
+                                        <p:strVal val="visible"/>
+                                      </p:to>
+                                    </p:set>
+                                  </p:childTnLst>
+                                </p:cTn>
+                              </p:par>
+                              <p:par>
+                                <p:cTn id="11" presetID="1" presetClass="entr" presetSubtype="0" fill="hold" grpId="0" nodeType="withEffect">
+                                  <p:stCondLst>
+                                    <p:cond delay="0"/>
+                                  </p:stCondLst>
+                                  <p:childTnLst>
+                                    <p:set>
+                                      <p:cBhvr>
+                                        <p:cTn id="12" dur="1" fill="hold">
+                                          <p:stCondLst>
+                                            <p:cond delay="0"/>
+                                          </p:stCondLst>
+                                        </p:cTn>
+                                        <p:tgtEl>
+                                          <p:spTgt spid="43"/>
+                                        </p:tgtEl>
+                                        <p:attrNameLst>
+                                          <p:attrName>style.visibility</p:attrName>
+                                        </p:attrNameLst>
+                                      </p:cBhvr>
+                                      <p:to>
+                                        <p:strVal val="visible"/>
+                                      </p:to>
+                                    </p:set>
+                                  </p:childTnLst>
+                                </p:cTn>
+                              </p:par>
+                              <p:par>
+                                <p:cTn id="13" presetID="1" presetClass="entr" presetSubtype="0" fill="hold" nodeType="withEffect">
+                                  <p:stCondLst>
+                                    <p:cond delay="0"/>
+                                  </p:stCondLst>
+                                  <p:childTnLst>
+                                    <p:set>
+                                      <p:cBhvr>
+                                        <p:cTn id="14" dur="1" fill="hold">
+                                          <p:stCondLst>
+                                            <p:cond delay="0"/>
+                                          </p:stCondLst>
+                                        </p:cTn>
+                                        <p:tgtEl>
+                                          <p:spTgt spid="47"/>
+                                        </p:tgtEl>
+                                        <p:attrNameLst>
+                                          <p:attrName>style.visibility</p:attrName>
+                                        </p:attrNameLst>
+                                      </p:cBhvr>
+                                      <p:to>
+                                        <p:strVal val="visible"/>
+                                      </p:to>
+                                    </p:set>
+                                  </p:childTnLst>
+                                </p:cTn>
+                              </p:par>
+                            </p:childTnLst>
+                          </p:cTn>
+                        </p:par>
+                      </p:childTnLst>
+                    </p:cTn>
+                  </p:par>
+                </p:childTnLst>
+              </p:cTn>
+              <p:prevCondLst>
+                <p:cond evt="onPrev" delay="0">
+                  <p:tgtEl>
+                    <p:sldTgt/>
+                  </p:tgtEl>
+                </p:cond>
+              </p:prevCondLst>
+              <p:nextCondLst>
+                <p:cond evt="onNext" delay="0">
+                  <p:tgtEl>
+                    <p:sldTgt/>
+                  </p:tgtEl>
+                </p:cond>
+              </p:nextCondLst>
+            </p:seq>
+          </p:childTnLst>
+        </p:cTn>
+      </p:par>
+    </p:tnLst>
+    <p:bldLst>
+      <p:bldP spid="43" grpId="0"/>
+    </p:bldLst>
+  </p:timing>
 </p:sld>
 </file>
 

</xml_diff>